<commit_message>
docs: Update presentation with no roles and fitted textboxes
</commit_message>
<xml_diff>
--- a/Quota_Management_and_Increase_Request_Planning_Presentation.pptx
+++ b/Quota_Management_and_Increase_Request_Planning_Presentation.pptx
@@ -3164,7 +3164,7 @@
           <a:solidFill>
             <a:srgbClr val="1E293B"/>
           </a:solidFill>
-          <a:ln w="25400">
+          <a:ln w="19050">
             <a:solidFill>
               <a:srgbClr val="3B82F6"/>
             </a:solidFill>
@@ -3185,11 +3185,11 @@
           </a:fontRef>
         </p:style>
         <p:txBody>
-          <a:bodyPr rtlCol="0" anchor="ctr" wrap="square" lIns="365760" rIns="365760" tIns="365760"/>
+          <a:bodyPr rtlCol="0" anchor="ctr" wrap="square" lIns="320040" rIns="320040" tIns="320040"/>
           <a:lstStyle/>
           <a:p>
             <a:pPr algn="ctr">
-              <a:defRPr sz="1100" b="1">
+              <a:defRPr sz="1000" b="1">
                 <a:solidFill>
                   <a:srgbClr val="06B6D4"/>
                 </a:solidFill>
@@ -3202,9 +3202,9 @@
           <a:p>
             <a:pPr>
               <a:spcBef>
-                <a:spcPts val="1000"/>
-              </a:spcBef>
-              <a:defRPr sz="2500" b="1">
+                <a:spcPts val="800"/>
+              </a:spcBef>
+              <a:defRPr sz="2300" b="1">
                 <a:solidFill>
                   <a:srgbClr val="F8FAFC"/>
                 </a:solidFill>
@@ -3221,9 +3221,9 @@
           <a:p>
             <a:pPr>
               <a:spcBef>
-                <a:spcPts val="1000"/>
-              </a:spcBef>
-              <a:defRPr sz="1100">
+                <a:spcPts val="800"/>
+              </a:spcBef>
+              <a:defRPr sz="1000">
                 <a:solidFill>
                   <a:srgbClr val="94A3B8"/>
                 </a:solidFill>
@@ -3236,76 +3236,76 @@
           <a:p>
             <a:pPr>
               <a:spcBef>
-                <a:spcPts val="2000"/>
-              </a:spcBef>
-              <a:defRPr sz="1100" b="1">
+                <a:spcPts val="1600"/>
+              </a:spcBef>
+              <a:defRPr sz="1000" b="1">
                 <a:solidFill>
                   <a:srgbClr val="F59E0B"/>
                 </a:solidFill>
               </a:defRPr>
             </a:pPr>
             <a:r>
-              <a:t>PROJECT TEAM MEMBERS:</a:t>
-            </a:r>
-          </a:p>
-          <a:p>
-            <a:pPr>
-              <a:spcBef>
-                <a:spcPts val="200"/>
-              </a:spcBef>
-              <a:defRPr sz="1050">
+              <a:t>TEAM MEMBERS:</a:t>
+            </a:r>
+          </a:p>
+          <a:p>
+            <a:pPr>
+              <a:spcBef>
+                <a:spcPts val="250"/>
+              </a:spcBef>
+              <a:defRPr sz="1000">
                 <a:solidFill>
                   <a:srgbClr val="F8FAFC"/>
                 </a:solidFill>
               </a:defRPr>
             </a:pPr>
             <a:r>
-              <a:t>•  YADAMAKANTI NAVANEETH REDDY  [2400030020]</a:t>
-            </a:r>
-          </a:p>
-          <a:p>
-            <a:pPr>
-              <a:spcBef>
-                <a:spcPts val="200"/>
-              </a:spcBef>
-              <a:defRPr sz="1050">
+              <a:t>•  2400030020  —  YADAMAKANTI NAVANEETH REDDY</a:t>
+            </a:r>
+          </a:p>
+          <a:p>
+            <a:pPr>
+              <a:spcBef>
+                <a:spcPts val="250"/>
+              </a:spcBef>
+              <a:defRPr sz="1000">
                 <a:solidFill>
                   <a:srgbClr val="F8FAFC"/>
                 </a:solidFill>
               </a:defRPr>
             </a:pPr>
             <a:r>
-              <a:t>•  SHIVAM KUMAR SAW  [2400039056]</a:t>
-            </a:r>
-          </a:p>
-          <a:p>
-            <a:pPr>
-              <a:spcBef>
-                <a:spcPts val="200"/>
-              </a:spcBef>
-              <a:defRPr sz="1050">
+              <a:t>•  2400039056  —  SHIVAM KUMAR SAW</a:t>
+            </a:r>
+          </a:p>
+          <a:p>
+            <a:pPr>
+              <a:spcBef>
+                <a:spcPts val="250"/>
+              </a:spcBef>
+              <a:defRPr sz="1000">
                 <a:solidFill>
                   <a:srgbClr val="F8FAFC"/>
                 </a:solidFill>
               </a:defRPr>
             </a:pPr>
             <a:r>
-              <a:t>•  NIKET KUMAR  [2400033292]</a:t>
-            </a:r>
-          </a:p>
-          <a:p>
-            <a:pPr>
-              <a:spcBef>
-                <a:spcPts val="200"/>
-              </a:spcBef>
-              <a:defRPr sz="1050">
+              <a:t>•  2400033292  —  NIKET KUMAR</a:t>
+            </a:r>
+          </a:p>
+          <a:p>
+            <a:pPr>
+              <a:spcBef>
+                <a:spcPts val="250"/>
+              </a:spcBef>
+              <a:defRPr sz="1000">
                 <a:solidFill>
                   <a:srgbClr val="F8FAFC"/>
                 </a:solidFill>
               </a:defRPr>
             </a:pPr>
             <a:r>
-              <a:t>•  ALLAM SAHITHI  [2400033195]</a:t>
+              <a:t>•  2400033195  —  ALLAM SAHITHI</a:t>
             </a:r>
           </a:p>
         </p:txBody>
@@ -3343,7 +3343,7 @@
         <p:spPr>
           <a:xfrm>
             <a:off x="731520" y="6309360"/>
-            <a:ext cx="10728655" cy="365760"/>
+            <a:ext cx="10728655" cy="320040"/>
           </a:xfrm>
           <a:prstGeom prst="rect">
             <a:avLst/>
@@ -3357,14 +3357,14 @@
           <a:lstStyle/>
           <a:p>
             <a:pPr>
-              <a:defRPr sz="900">
+              <a:defRPr sz="850">
                 <a:solidFill>
                   <a:srgbClr val="64748B"/>
                 </a:solidFill>
               </a:defRPr>
             </a:pPr>
             <a:r>
-              <a:t>Google Cloud Hackathon 2026 | Quota Management Control Plane  •  Slide 1 of 17  •  Team: Y. Navaneeth Reddy, Shivam Kumar, Niket Kumar, Allam Sahithi</a:t>
+              <a:t>Google Cloud Hackathon 2026 | Quota Management Control Plane  •  Slide 1 of 17</a:t>
             </a:r>
           </a:p>
         </p:txBody>
@@ -3438,8 +3438,8 @@
         </p:nvSpPr>
         <p:spPr>
           <a:xfrm>
-            <a:off x="731520" y="457200"/>
-            <a:ext cx="4572000" cy="365760"/>
+            <a:off x="731520" y="411480"/>
+            <a:ext cx="5486400" cy="320040"/>
           </a:xfrm>
           <a:prstGeom prst="rect">
             <a:avLst/>
@@ -3453,7 +3453,7 @@
           <a:lstStyle/>
           <a:p>
             <a:pPr>
-              <a:defRPr sz="1000" b="1">
+              <a:defRPr sz="950" b="1">
                 <a:solidFill>
                   <a:srgbClr val="06B6D4"/>
                 </a:solidFill>
@@ -3473,8 +3473,8 @@
         </p:nvSpPr>
         <p:spPr>
           <a:xfrm>
-            <a:off x="731520" y="777240"/>
-            <a:ext cx="10515600" cy="731520"/>
+            <a:off x="731520" y="685800"/>
+            <a:ext cx="10515600" cy="594360"/>
           </a:xfrm>
           <a:prstGeom prst="rect">
             <a:avLst/>
@@ -3488,7 +3488,7 @@
           <a:lstStyle/>
           <a:p>
             <a:pPr>
-              <a:defRPr sz="2200" b="1">
+              <a:defRPr sz="2000" b="1">
                 <a:solidFill>
                   <a:srgbClr val="F8FAFC"/>
                 </a:solidFill>
@@ -3508,7 +3508,7 @@
         </p:nvSpPr>
         <p:spPr>
           <a:xfrm>
-            <a:off x="731520" y="1371600"/>
+            <a:off x="731520" y="1234440"/>
             <a:ext cx="10515600" cy="365760"/>
           </a:xfrm>
           <a:prstGeom prst="rect">
@@ -3523,7 +3523,7 @@
           <a:lstStyle/>
           <a:p>
             <a:pPr>
-              <a:defRPr sz="1200">
+              <a:defRPr sz="1100">
                 <a:solidFill>
                   <a:srgbClr val="94A3B8"/>
                 </a:solidFill>
@@ -3543,8 +3543,8 @@
         </p:nvSpPr>
         <p:spPr>
           <a:xfrm>
-            <a:off x="731520" y="1828800"/>
-            <a:ext cx="5486400" cy="4297680"/>
+            <a:off x="731520" y="1691640"/>
+            <a:ext cx="5486400" cy="4434840"/>
           </a:xfrm>
           <a:prstGeom prst="roundRect">
             <a:avLst/>
@@ -3573,14 +3573,14 @@
           </a:fontRef>
         </p:style>
         <p:txBody>
-          <a:bodyPr rtlCol="0" anchor="ctr" wrap="square" lIns="274320" rIns="274320" tIns="274320"/>
+          <a:bodyPr rtlCol="0" anchor="ctr" wrap="square" lIns="228600" rIns="228600" tIns="228600" bIns="182880"/>
           <a:lstStyle/>
           <a:p>
             <a:pPr algn="ctr">
               <a:spcBef>
                 <a:spcPts val="0"/>
               </a:spcBef>
-              <a:defRPr b="1" sz="1300">
+              <a:defRPr b="1" sz="1100">
                 <a:solidFill>
                   <a:srgbClr val="3B82F6"/>
                 </a:solidFill>
@@ -3593,9 +3593,9 @@
           <a:p>
             <a:pPr>
               <a:spcBef>
-                <a:spcPts val="200"/>
-              </a:spcBef>
-              <a:defRPr sz="1100">
+                <a:spcPts val="150"/>
+              </a:spcBef>
+              <a:defRPr sz="950">
                 <a:solidFill>
                   <a:srgbClr val="F8FAFC"/>
                 </a:solidFill>
@@ -3608,9 +3608,9 @@
           <a:p>
             <a:pPr>
               <a:spcBef>
-                <a:spcPts val="800"/>
-              </a:spcBef>
-              <a:defRPr b="1" sz="1300">
+                <a:spcPts val="500"/>
+              </a:spcBef>
+              <a:defRPr b="1" sz="1100">
                 <a:solidFill>
                   <a:srgbClr val="06B6D4"/>
                 </a:solidFill>
@@ -3623,9 +3623,9 @@
           <a:p>
             <a:pPr>
               <a:spcBef>
-                <a:spcPts val="200"/>
-              </a:spcBef>
-              <a:defRPr sz="1100">
+                <a:spcPts val="150"/>
+              </a:spcBef>
+              <a:defRPr sz="950">
                 <a:solidFill>
                   <a:srgbClr val="F8FAFC"/>
                 </a:solidFill>
@@ -3638,9 +3638,9 @@
           <a:p>
             <a:pPr>
               <a:spcBef>
-                <a:spcPts val="800"/>
-              </a:spcBef>
-              <a:defRPr b="1" sz="1300">
+                <a:spcPts val="500"/>
+              </a:spcBef>
+              <a:defRPr b="1" sz="1100">
                 <a:solidFill>
                   <a:srgbClr val="3B82F6"/>
                 </a:solidFill>
@@ -3653,9 +3653,9 @@
           <a:p>
             <a:pPr>
               <a:spcBef>
-                <a:spcPts val="200"/>
-              </a:spcBef>
-              <a:defRPr sz="1100">
+                <a:spcPts val="150"/>
+              </a:spcBef>
+              <a:defRPr sz="950">
                 <a:solidFill>
                   <a:srgbClr val="F8FAFC"/>
                 </a:solidFill>
@@ -3668,9 +3668,9 @@
           <a:p>
             <a:pPr>
               <a:spcBef>
-                <a:spcPts val="800"/>
-              </a:spcBef>
-              <a:defRPr b="1" sz="1300">
+                <a:spcPts val="500"/>
+              </a:spcBef>
+              <a:defRPr b="1" sz="1100">
                 <a:solidFill>
                   <a:srgbClr val="06B6D4"/>
                 </a:solidFill>
@@ -3683,9 +3683,9 @@
           <a:p>
             <a:pPr>
               <a:spcBef>
-                <a:spcPts val="200"/>
-              </a:spcBef>
-              <a:defRPr sz="1100">
+                <a:spcPts val="150"/>
+              </a:spcBef>
+              <a:defRPr sz="950">
                 <a:solidFill>
                   <a:srgbClr val="F8FAFC"/>
                 </a:solidFill>
@@ -3713,8 +3713,8 @@
         </p:blipFill>
         <p:spPr>
           <a:xfrm>
-            <a:off x="6492240" y="1828800"/>
-            <a:ext cx="4937760" cy="4297680"/>
+            <a:off x="6492240" y="1691640"/>
+            <a:ext cx="4937760" cy="4434840"/>
           </a:xfrm>
           <a:prstGeom prst="rect">
             <a:avLst/>
@@ -3730,7 +3730,7 @@
         <p:spPr>
           <a:xfrm>
             <a:off x="731520" y="6309360"/>
-            <a:ext cx="10728655" cy="365760"/>
+            <a:ext cx="10728655" cy="320040"/>
           </a:xfrm>
           <a:prstGeom prst="rect">
             <a:avLst/>
@@ -3744,14 +3744,14 @@
           <a:lstStyle/>
           <a:p>
             <a:pPr>
-              <a:defRPr sz="900">
+              <a:defRPr sz="850">
                 <a:solidFill>
                   <a:srgbClr val="64748B"/>
                 </a:solidFill>
               </a:defRPr>
             </a:pPr>
             <a:r>
-              <a:t>Google Cloud Hackathon 2026 | Quota Management Control Plane  •  Slide 10 of 17  •  Team: Y. Navaneeth Reddy, Shivam Kumar, Niket Kumar, Allam Sahithi</a:t>
+              <a:t>Google Cloud Hackathon 2026 | Quota Management Control Plane  •  Slide 10 of 17</a:t>
             </a:r>
           </a:p>
         </p:txBody>
@@ -3825,8 +3825,8 @@
         </p:nvSpPr>
         <p:spPr>
           <a:xfrm>
-            <a:off x="731520" y="457200"/>
-            <a:ext cx="4572000" cy="365760"/>
+            <a:off x="731520" y="411480"/>
+            <a:ext cx="5486400" cy="320040"/>
           </a:xfrm>
           <a:prstGeom prst="rect">
             <a:avLst/>
@@ -3840,7 +3840,7 @@
           <a:lstStyle/>
           <a:p>
             <a:pPr>
-              <a:defRPr sz="1000" b="1">
+              <a:defRPr sz="950" b="1">
                 <a:solidFill>
                   <a:srgbClr val="06B6D4"/>
                 </a:solidFill>
@@ -3860,8 +3860,8 @@
         </p:nvSpPr>
         <p:spPr>
           <a:xfrm>
-            <a:off x="731520" y="777240"/>
-            <a:ext cx="10515600" cy="731520"/>
+            <a:off x="731520" y="685800"/>
+            <a:ext cx="10515600" cy="594360"/>
           </a:xfrm>
           <a:prstGeom prst="rect">
             <a:avLst/>
@@ -3875,7 +3875,7 @@
           <a:lstStyle/>
           <a:p>
             <a:pPr>
-              <a:defRPr sz="2200" b="1">
+              <a:defRPr sz="2000" b="1">
                 <a:solidFill>
                   <a:srgbClr val="F8FAFC"/>
                 </a:solidFill>
@@ -3895,7 +3895,7 @@
         </p:nvSpPr>
         <p:spPr>
           <a:xfrm>
-            <a:off x="731520" y="1371600"/>
+            <a:off x="731520" y="1234440"/>
             <a:ext cx="10515600" cy="365760"/>
           </a:xfrm>
           <a:prstGeom prst="rect">
@@ -3910,7 +3910,7 @@
           <a:lstStyle/>
           <a:p>
             <a:pPr>
-              <a:defRPr sz="1200">
+              <a:defRPr sz="1100">
                 <a:solidFill>
                   <a:srgbClr val="94A3B8"/>
                 </a:solidFill>
@@ -3930,8 +3930,8 @@
         </p:nvSpPr>
         <p:spPr>
           <a:xfrm>
-            <a:off x="731520" y="1828800"/>
-            <a:ext cx="5486400" cy="4297680"/>
+            <a:off x="731520" y="1691640"/>
+            <a:ext cx="5486400" cy="4434840"/>
           </a:xfrm>
           <a:prstGeom prst="roundRect">
             <a:avLst/>
@@ -3960,14 +3960,14 @@
           </a:fontRef>
         </p:style>
         <p:txBody>
-          <a:bodyPr rtlCol="0" anchor="ctr" wrap="square" lIns="274320" rIns="274320" tIns="274320"/>
+          <a:bodyPr rtlCol="0" anchor="ctr" wrap="square" lIns="228600" rIns="228600" tIns="228600" bIns="182880"/>
           <a:lstStyle/>
           <a:p>
             <a:pPr algn="ctr">
               <a:spcBef>
                 <a:spcPts val="0"/>
               </a:spcBef>
-              <a:defRPr b="1" sz="1300">
+              <a:defRPr b="1" sz="1100">
                 <a:solidFill>
                   <a:srgbClr val="3B82F6"/>
                 </a:solidFill>
@@ -3980,9 +3980,9 @@
           <a:p>
             <a:pPr>
               <a:spcBef>
-                <a:spcPts val="200"/>
-              </a:spcBef>
-              <a:defRPr sz="1100">
+                <a:spcPts val="150"/>
+              </a:spcBef>
+              <a:defRPr sz="950">
                 <a:solidFill>
                   <a:srgbClr val="F8FAFC"/>
                 </a:solidFill>
@@ -3995,9 +3995,9 @@
           <a:p>
             <a:pPr>
               <a:spcBef>
-                <a:spcPts val="800"/>
-              </a:spcBef>
-              <a:defRPr b="1" sz="1300">
+                <a:spcPts val="500"/>
+              </a:spcBef>
+              <a:defRPr b="1" sz="1100">
                 <a:solidFill>
                   <a:srgbClr val="06B6D4"/>
                 </a:solidFill>
@@ -4010,9 +4010,9 @@
           <a:p>
             <a:pPr>
               <a:spcBef>
-                <a:spcPts val="200"/>
-              </a:spcBef>
-              <a:defRPr sz="1100">
+                <a:spcPts val="150"/>
+              </a:spcBef>
+              <a:defRPr sz="950">
                 <a:solidFill>
                   <a:srgbClr val="F8FAFC"/>
                 </a:solidFill>
@@ -4025,9 +4025,9 @@
           <a:p>
             <a:pPr>
               <a:spcBef>
-                <a:spcPts val="800"/>
-              </a:spcBef>
-              <a:defRPr b="1" sz="1300">
+                <a:spcPts val="500"/>
+              </a:spcBef>
+              <a:defRPr b="1" sz="1100">
                 <a:solidFill>
                   <a:srgbClr val="3B82F6"/>
                 </a:solidFill>
@@ -4040,9 +4040,9 @@
           <a:p>
             <a:pPr>
               <a:spcBef>
-                <a:spcPts val="200"/>
-              </a:spcBef>
-              <a:defRPr sz="1100">
+                <a:spcPts val="150"/>
+              </a:spcBef>
+              <a:defRPr sz="950">
                 <a:solidFill>
                   <a:srgbClr val="F8FAFC"/>
                 </a:solidFill>
@@ -4055,9 +4055,9 @@
           <a:p>
             <a:pPr>
               <a:spcBef>
-                <a:spcPts val="800"/>
-              </a:spcBef>
-              <a:defRPr b="1" sz="1300">
+                <a:spcPts val="500"/>
+              </a:spcBef>
+              <a:defRPr b="1" sz="1100">
                 <a:solidFill>
                   <a:srgbClr val="06B6D4"/>
                 </a:solidFill>
@@ -4070,9 +4070,9 @@
           <a:p>
             <a:pPr>
               <a:spcBef>
-                <a:spcPts val="200"/>
-              </a:spcBef>
-              <a:defRPr sz="1100">
+                <a:spcPts val="150"/>
+              </a:spcBef>
+              <a:defRPr sz="950">
                 <a:solidFill>
                   <a:srgbClr val="F8FAFC"/>
                 </a:solidFill>
@@ -4100,8 +4100,8 @@
         </p:blipFill>
         <p:spPr>
           <a:xfrm>
-            <a:off x="6492240" y="1828800"/>
-            <a:ext cx="4937760" cy="4297680"/>
+            <a:off x="6492240" y="1691640"/>
+            <a:ext cx="4937760" cy="4434840"/>
           </a:xfrm>
           <a:prstGeom prst="rect">
             <a:avLst/>
@@ -4117,7 +4117,7 @@
         <p:spPr>
           <a:xfrm>
             <a:off x="731520" y="6309360"/>
-            <a:ext cx="10728655" cy="365760"/>
+            <a:ext cx="10728655" cy="320040"/>
           </a:xfrm>
           <a:prstGeom prst="rect">
             <a:avLst/>
@@ -4131,14 +4131,14 @@
           <a:lstStyle/>
           <a:p>
             <a:pPr>
-              <a:defRPr sz="900">
+              <a:defRPr sz="850">
                 <a:solidFill>
                   <a:srgbClr val="64748B"/>
                 </a:solidFill>
               </a:defRPr>
             </a:pPr>
             <a:r>
-              <a:t>Google Cloud Hackathon 2026 | Quota Management Control Plane  •  Slide 11 of 17  •  Team: Y. Navaneeth Reddy, Shivam Kumar, Niket Kumar, Allam Sahithi</a:t>
+              <a:t>Google Cloud Hackathon 2026 | Quota Management Control Plane  •  Slide 11 of 17</a:t>
             </a:r>
           </a:p>
         </p:txBody>
@@ -4212,8 +4212,8 @@
         </p:nvSpPr>
         <p:spPr>
           <a:xfrm>
-            <a:off x="731520" y="457200"/>
-            <a:ext cx="4572000" cy="365760"/>
+            <a:off x="731520" y="411480"/>
+            <a:ext cx="5486400" cy="320040"/>
           </a:xfrm>
           <a:prstGeom prst="rect">
             <a:avLst/>
@@ -4227,7 +4227,7 @@
           <a:lstStyle/>
           <a:p>
             <a:pPr>
-              <a:defRPr sz="1000" b="1">
+              <a:defRPr sz="950" b="1">
                 <a:solidFill>
                   <a:srgbClr val="06B6D4"/>
                 </a:solidFill>
@@ -4247,8 +4247,8 @@
         </p:nvSpPr>
         <p:spPr>
           <a:xfrm>
-            <a:off x="731520" y="777240"/>
-            <a:ext cx="10515600" cy="731520"/>
+            <a:off x="731520" y="685800"/>
+            <a:ext cx="10515600" cy="594360"/>
           </a:xfrm>
           <a:prstGeom prst="rect">
             <a:avLst/>
@@ -4262,7 +4262,7 @@
           <a:lstStyle/>
           <a:p>
             <a:pPr>
-              <a:defRPr sz="2200" b="1">
+              <a:defRPr sz="2000" b="1">
                 <a:solidFill>
                   <a:srgbClr val="F8FAFC"/>
                 </a:solidFill>
@@ -4282,7 +4282,7 @@
         </p:nvSpPr>
         <p:spPr>
           <a:xfrm>
-            <a:off x="731520" y="1371600"/>
+            <a:off x="731520" y="1234440"/>
             <a:ext cx="10515600" cy="365760"/>
           </a:xfrm>
           <a:prstGeom prst="rect">
@@ -4297,7 +4297,7 @@
           <a:lstStyle/>
           <a:p>
             <a:pPr>
-              <a:defRPr sz="1200">
+              <a:defRPr sz="1100">
                 <a:solidFill>
                   <a:srgbClr val="94A3B8"/>
                 </a:solidFill>
@@ -4317,8 +4317,8 @@
         </p:nvSpPr>
         <p:spPr>
           <a:xfrm>
-            <a:off x="731520" y="1828800"/>
-            <a:ext cx="5486400" cy="4297680"/>
+            <a:off x="731520" y="1691640"/>
+            <a:ext cx="5486400" cy="4434840"/>
           </a:xfrm>
           <a:prstGeom prst="roundRect">
             <a:avLst/>
@@ -4347,14 +4347,14 @@
           </a:fontRef>
         </p:style>
         <p:txBody>
-          <a:bodyPr rtlCol="0" anchor="ctr" wrap="square" lIns="274320" rIns="274320" tIns="274320"/>
+          <a:bodyPr rtlCol="0" anchor="ctr" wrap="square" lIns="228600" rIns="228600" tIns="228600" bIns="182880"/>
           <a:lstStyle/>
           <a:p>
             <a:pPr algn="ctr">
               <a:spcBef>
                 <a:spcPts val="0"/>
               </a:spcBef>
-              <a:defRPr b="1" sz="1300">
+              <a:defRPr b="1" sz="1100">
                 <a:solidFill>
                   <a:srgbClr val="3B82F6"/>
                 </a:solidFill>
@@ -4367,9 +4367,9 @@
           <a:p>
             <a:pPr>
               <a:spcBef>
-                <a:spcPts val="200"/>
-              </a:spcBef>
-              <a:defRPr sz="1100">
+                <a:spcPts val="150"/>
+              </a:spcBef>
+              <a:defRPr sz="950">
                 <a:solidFill>
                   <a:srgbClr val="F8FAFC"/>
                 </a:solidFill>
@@ -4382,9 +4382,9 @@
           <a:p>
             <a:pPr>
               <a:spcBef>
-                <a:spcPts val="800"/>
-              </a:spcBef>
-              <a:defRPr b="1" sz="1300">
+                <a:spcPts val="500"/>
+              </a:spcBef>
+              <a:defRPr b="1" sz="1100">
                 <a:solidFill>
                   <a:srgbClr val="06B6D4"/>
                 </a:solidFill>
@@ -4397,24 +4397,24 @@
           <a:p>
             <a:pPr>
               <a:spcBef>
-                <a:spcPts val="200"/>
-              </a:spcBef>
-              <a:defRPr sz="1100">
+                <a:spcPts val="150"/>
+              </a:spcBef>
+              <a:defRPr sz="950">
                 <a:solidFill>
                   <a:srgbClr val="F8FAFC"/>
                 </a:solidFill>
               </a:defRPr>
             </a:pPr>
             <a:r>
-              <a:t>    Handles transient network timeouts and rate limits (429/503) using truncated exponential backoff (t = min(t_max, t_base × 2^attempt) + jitter).</a:t>
-            </a:r>
-          </a:p>
-          <a:p>
-            <a:pPr>
-              <a:spcBef>
-                <a:spcPts val="800"/>
-              </a:spcBef>
-              <a:defRPr b="1" sz="1300">
+              <a:t>    Handles transient network timeouts and rate limits (429/503) using truncated exponential backoff.</a:t>
+            </a:r>
+          </a:p>
+          <a:p>
+            <a:pPr>
+              <a:spcBef>
+                <a:spcPts val="500"/>
+              </a:spcBef>
+              <a:defRPr b="1" sz="1100">
                 <a:solidFill>
                   <a:srgbClr val="3B82F6"/>
                 </a:solidFill>
@@ -4427,9 +4427,9 @@
           <a:p>
             <a:pPr>
               <a:spcBef>
-                <a:spcPts val="200"/>
-              </a:spcBef>
-              <a:defRPr sz="1100">
+                <a:spcPts val="150"/>
+              </a:spcBef>
+              <a:defRPr sz="950">
                 <a:solidFill>
                   <a:srgbClr val="F8FAFC"/>
                 </a:solidFill>
@@ -4442,9 +4442,9 @@
           <a:p>
             <a:pPr>
               <a:spcBef>
-                <a:spcPts val="800"/>
-              </a:spcBef>
-              <a:defRPr b="1" sz="1300">
+                <a:spcPts val="500"/>
+              </a:spcBef>
+              <a:defRPr b="1" sz="1100">
                 <a:solidFill>
                   <a:srgbClr val="06B6D4"/>
                 </a:solidFill>
@@ -4457,9 +4457,9 @@
           <a:p>
             <a:pPr>
               <a:spcBef>
-                <a:spcPts val="200"/>
-              </a:spcBef>
-              <a:defRPr sz="1100">
+                <a:spcPts val="150"/>
+              </a:spcBef>
+              <a:defRPr sz="950">
                 <a:solidFill>
                   <a:srgbClr val="F8FAFC"/>
                 </a:solidFill>
@@ -4487,8 +4487,8 @@
         </p:blipFill>
         <p:spPr>
           <a:xfrm>
-            <a:off x="6492240" y="1828800"/>
-            <a:ext cx="4937760" cy="4297680"/>
+            <a:off x="6492240" y="1691640"/>
+            <a:ext cx="4937760" cy="4434840"/>
           </a:xfrm>
           <a:prstGeom prst="rect">
             <a:avLst/>
@@ -4504,7 +4504,7 @@
         <p:spPr>
           <a:xfrm>
             <a:off x="731520" y="6309360"/>
-            <a:ext cx="10728655" cy="365760"/>
+            <a:ext cx="10728655" cy="320040"/>
           </a:xfrm>
           <a:prstGeom prst="rect">
             <a:avLst/>
@@ -4518,14 +4518,14 @@
           <a:lstStyle/>
           <a:p>
             <a:pPr>
-              <a:defRPr sz="900">
+              <a:defRPr sz="850">
                 <a:solidFill>
                   <a:srgbClr val="64748B"/>
                 </a:solidFill>
               </a:defRPr>
             </a:pPr>
             <a:r>
-              <a:t>Google Cloud Hackathon 2026 | Quota Management Control Plane  •  Slide 12 of 17  •  Team: Y. Navaneeth Reddy, Shivam Kumar, Niket Kumar, Allam Sahithi</a:t>
+              <a:t>Google Cloud Hackathon 2026 | Quota Management Control Plane  •  Slide 12 of 17</a:t>
             </a:r>
           </a:p>
         </p:txBody>
@@ -4599,8 +4599,8 @@
         </p:nvSpPr>
         <p:spPr>
           <a:xfrm>
-            <a:off x="731520" y="457200"/>
-            <a:ext cx="4572000" cy="365760"/>
+            <a:off x="731520" y="411480"/>
+            <a:ext cx="5486400" cy="320040"/>
           </a:xfrm>
           <a:prstGeom prst="rect">
             <a:avLst/>
@@ -4614,7 +4614,7 @@
           <a:lstStyle/>
           <a:p>
             <a:pPr>
-              <a:defRPr sz="1000" b="1">
+              <a:defRPr sz="950" b="1">
                 <a:solidFill>
                   <a:srgbClr val="06B6D4"/>
                 </a:solidFill>
@@ -4634,8 +4634,8 @@
         </p:nvSpPr>
         <p:spPr>
           <a:xfrm>
-            <a:off x="731520" y="777240"/>
-            <a:ext cx="10515600" cy="731520"/>
+            <a:off x="731520" y="685800"/>
+            <a:ext cx="10515600" cy="594360"/>
           </a:xfrm>
           <a:prstGeom prst="rect">
             <a:avLst/>
@@ -4649,7 +4649,7 @@
           <a:lstStyle/>
           <a:p>
             <a:pPr>
-              <a:defRPr sz="2200" b="1">
+              <a:defRPr sz="2000" b="1">
                 <a:solidFill>
                   <a:srgbClr val="F8FAFC"/>
                 </a:solidFill>
@@ -4669,7 +4669,7 @@
         </p:nvSpPr>
         <p:spPr>
           <a:xfrm>
-            <a:off x="731520" y="1371600"/>
+            <a:off x="731520" y="1234440"/>
             <a:ext cx="10515600" cy="365760"/>
           </a:xfrm>
           <a:prstGeom prst="rect">
@@ -4684,7 +4684,7 @@
           <a:lstStyle/>
           <a:p>
             <a:pPr>
-              <a:defRPr sz="1200">
+              <a:defRPr sz="1100">
                 <a:solidFill>
                   <a:srgbClr val="94A3B8"/>
                 </a:solidFill>
@@ -4704,8 +4704,8 @@
         </p:nvSpPr>
         <p:spPr>
           <a:xfrm>
-            <a:off x="731520" y="1828800"/>
-            <a:ext cx="5486400" cy="4297680"/>
+            <a:off x="731520" y="1691640"/>
+            <a:ext cx="5486400" cy="4434840"/>
           </a:xfrm>
           <a:prstGeom prst="roundRect">
             <a:avLst/>
@@ -4734,14 +4734,14 @@
           </a:fontRef>
         </p:style>
         <p:txBody>
-          <a:bodyPr rtlCol="0" anchor="ctr" wrap="square" lIns="274320" rIns="274320" tIns="274320"/>
+          <a:bodyPr rtlCol="0" anchor="ctr" wrap="square" lIns="228600" rIns="228600" tIns="228600" bIns="182880"/>
           <a:lstStyle/>
           <a:p>
             <a:pPr algn="ctr">
               <a:spcBef>
                 <a:spcPts val="0"/>
               </a:spcBef>
-              <a:defRPr b="1" sz="1300">
+              <a:defRPr b="1" sz="1100">
                 <a:solidFill>
                   <a:srgbClr val="3B82F6"/>
                 </a:solidFill>
@@ -4754,9 +4754,9 @@
           <a:p>
             <a:pPr>
               <a:spcBef>
-                <a:spcPts val="200"/>
-              </a:spcBef>
-              <a:defRPr sz="1100">
+                <a:spcPts val="150"/>
+              </a:spcBef>
+              <a:defRPr sz="950">
                 <a:solidFill>
                   <a:srgbClr val="F8FAFC"/>
                 </a:solidFill>
@@ -4769,9 +4769,9 @@
           <a:p>
             <a:pPr>
               <a:spcBef>
-                <a:spcPts val="800"/>
-              </a:spcBef>
-              <a:defRPr b="1" sz="1300">
+                <a:spcPts val="500"/>
+              </a:spcBef>
+              <a:defRPr b="1" sz="1100">
                 <a:solidFill>
                   <a:srgbClr val="06B6D4"/>
                 </a:solidFill>
@@ -4784,9 +4784,9 @@
           <a:p>
             <a:pPr>
               <a:spcBef>
-                <a:spcPts val="200"/>
-              </a:spcBef>
-              <a:defRPr sz="1100">
+                <a:spcPts val="150"/>
+              </a:spcBef>
+              <a:defRPr sz="950">
                 <a:solidFill>
                   <a:srgbClr val="F8FAFC"/>
                 </a:solidFill>
@@ -4799,9 +4799,9 @@
           <a:p>
             <a:pPr>
               <a:spcBef>
-                <a:spcPts val="800"/>
-              </a:spcBef>
-              <a:defRPr b="1" sz="1300">
+                <a:spcPts val="500"/>
+              </a:spcBef>
+              <a:defRPr b="1" sz="1100">
                 <a:solidFill>
                   <a:srgbClr val="3B82F6"/>
                 </a:solidFill>
@@ -4814,9 +4814,9 @@
           <a:p>
             <a:pPr>
               <a:spcBef>
-                <a:spcPts val="200"/>
-              </a:spcBef>
-              <a:defRPr sz="1100">
+                <a:spcPts val="150"/>
+              </a:spcBef>
+              <a:defRPr sz="950">
                 <a:solidFill>
                   <a:srgbClr val="F8FAFC"/>
                 </a:solidFill>
@@ -4829,9 +4829,9 @@
           <a:p>
             <a:pPr>
               <a:spcBef>
-                <a:spcPts val="800"/>
-              </a:spcBef>
-              <a:defRPr b="1" sz="1300">
+                <a:spcPts val="500"/>
+              </a:spcBef>
+              <a:defRPr b="1" sz="1100">
                 <a:solidFill>
                   <a:srgbClr val="06B6D4"/>
                 </a:solidFill>
@@ -4844,9 +4844,9 @@
           <a:p>
             <a:pPr>
               <a:spcBef>
-                <a:spcPts val="200"/>
-              </a:spcBef>
-              <a:defRPr sz="1100">
+                <a:spcPts val="150"/>
+              </a:spcBef>
+              <a:defRPr sz="950">
                 <a:solidFill>
                   <a:srgbClr val="F8FAFC"/>
                 </a:solidFill>
@@ -4874,8 +4874,8 @@
         </p:blipFill>
         <p:spPr>
           <a:xfrm>
-            <a:off x="6492240" y="1828800"/>
-            <a:ext cx="4937760" cy="4297680"/>
+            <a:off x="6492240" y="1691640"/>
+            <a:ext cx="4937760" cy="4434840"/>
           </a:xfrm>
           <a:prstGeom prst="rect">
             <a:avLst/>
@@ -4891,7 +4891,7 @@
         <p:spPr>
           <a:xfrm>
             <a:off x="731520" y="6309360"/>
-            <a:ext cx="10728655" cy="365760"/>
+            <a:ext cx="10728655" cy="320040"/>
           </a:xfrm>
           <a:prstGeom prst="rect">
             <a:avLst/>
@@ -4905,14 +4905,14 @@
           <a:lstStyle/>
           <a:p>
             <a:pPr>
-              <a:defRPr sz="900">
+              <a:defRPr sz="850">
                 <a:solidFill>
                   <a:srgbClr val="64748B"/>
                 </a:solidFill>
               </a:defRPr>
             </a:pPr>
             <a:r>
-              <a:t>Google Cloud Hackathon 2026 | Quota Management Control Plane  •  Slide 13 of 17  •  Team: Y. Navaneeth Reddy, Shivam Kumar, Niket Kumar, Allam Sahithi</a:t>
+              <a:t>Google Cloud Hackathon 2026 | Quota Management Control Plane  •  Slide 13 of 17</a:t>
             </a:r>
           </a:p>
         </p:txBody>
@@ -4986,8 +4986,8 @@
         </p:nvSpPr>
         <p:spPr>
           <a:xfrm>
-            <a:off x="731520" y="457200"/>
-            <a:ext cx="4572000" cy="365760"/>
+            <a:off x="731520" y="411480"/>
+            <a:ext cx="5486400" cy="320040"/>
           </a:xfrm>
           <a:prstGeom prst="rect">
             <a:avLst/>
@@ -5001,7 +5001,7 @@
           <a:lstStyle/>
           <a:p>
             <a:pPr>
-              <a:defRPr sz="1000" b="1">
+              <a:defRPr sz="950" b="1">
                 <a:solidFill>
                   <a:srgbClr val="06B6D4"/>
                 </a:solidFill>
@@ -5021,8 +5021,8 @@
         </p:nvSpPr>
         <p:spPr>
           <a:xfrm>
-            <a:off x="731520" y="777240"/>
-            <a:ext cx="10515600" cy="731520"/>
+            <a:off x="731520" y="685800"/>
+            <a:ext cx="10515600" cy="594360"/>
           </a:xfrm>
           <a:prstGeom prst="rect">
             <a:avLst/>
@@ -5036,7 +5036,7 @@
           <a:lstStyle/>
           <a:p>
             <a:pPr>
-              <a:defRPr sz="2200" b="1">
+              <a:defRPr sz="2000" b="1">
                 <a:solidFill>
                   <a:srgbClr val="F8FAFC"/>
                 </a:solidFill>
@@ -5056,7 +5056,7 @@
         </p:nvSpPr>
         <p:spPr>
           <a:xfrm>
-            <a:off x="731520" y="1371600"/>
+            <a:off x="731520" y="1234440"/>
             <a:ext cx="10515600" cy="365760"/>
           </a:xfrm>
           <a:prstGeom prst="rect">
@@ -5071,7 +5071,7 @@
           <a:lstStyle/>
           <a:p>
             <a:pPr>
-              <a:defRPr sz="1200">
+              <a:defRPr sz="1100">
                 <a:solidFill>
                   <a:srgbClr val="94A3B8"/>
                 </a:solidFill>
@@ -5091,8 +5091,8 @@
         </p:nvSpPr>
         <p:spPr>
           <a:xfrm>
-            <a:off x="731520" y="1828800"/>
-            <a:ext cx="5486400" cy="4297680"/>
+            <a:off x="731520" y="1691640"/>
+            <a:ext cx="5486400" cy="4434840"/>
           </a:xfrm>
           <a:prstGeom prst="roundRect">
             <a:avLst/>
@@ -5121,14 +5121,14 @@
           </a:fontRef>
         </p:style>
         <p:txBody>
-          <a:bodyPr rtlCol="0" anchor="ctr" wrap="square" lIns="274320" rIns="274320" tIns="274320"/>
+          <a:bodyPr rtlCol="0" anchor="ctr" wrap="square" lIns="228600" rIns="228600" tIns="228600" bIns="182880"/>
           <a:lstStyle/>
           <a:p>
             <a:pPr algn="ctr">
               <a:spcBef>
                 <a:spcPts val="0"/>
               </a:spcBef>
-              <a:defRPr b="1" sz="1300">
+              <a:defRPr b="1" sz="1100">
                 <a:solidFill>
                   <a:srgbClr val="3B82F6"/>
                 </a:solidFill>
@@ -5141,9 +5141,9 @@
           <a:p>
             <a:pPr>
               <a:spcBef>
-                <a:spcPts val="200"/>
-              </a:spcBef>
-              <a:defRPr sz="1100">
+                <a:spcPts val="150"/>
+              </a:spcBef>
+              <a:defRPr sz="950">
                 <a:solidFill>
                   <a:srgbClr val="F8FAFC"/>
                 </a:solidFill>
@@ -5156,9 +5156,9 @@
           <a:p>
             <a:pPr>
               <a:spcBef>
-                <a:spcPts val="800"/>
-              </a:spcBef>
-              <a:defRPr b="1" sz="1300">
+                <a:spcPts val="500"/>
+              </a:spcBef>
+              <a:defRPr b="1" sz="1100">
                 <a:solidFill>
                   <a:srgbClr val="06B6D4"/>
                 </a:solidFill>
@@ -5171,9 +5171,9 @@
           <a:p>
             <a:pPr>
               <a:spcBef>
-                <a:spcPts val="200"/>
-              </a:spcBef>
-              <a:defRPr sz="1100">
+                <a:spcPts val="150"/>
+              </a:spcBef>
+              <a:defRPr sz="950">
                 <a:solidFill>
                   <a:srgbClr val="F8FAFC"/>
                 </a:solidFill>
@@ -5186,9 +5186,9 @@
           <a:p>
             <a:pPr>
               <a:spcBef>
-                <a:spcPts val="800"/>
-              </a:spcBef>
-              <a:defRPr b="1" sz="1300">
+                <a:spcPts val="500"/>
+              </a:spcBef>
+              <a:defRPr b="1" sz="1100">
                 <a:solidFill>
                   <a:srgbClr val="3B82F6"/>
                 </a:solidFill>
@@ -5201,9 +5201,9 @@
           <a:p>
             <a:pPr>
               <a:spcBef>
-                <a:spcPts val="200"/>
-              </a:spcBef>
-              <a:defRPr sz="1100">
+                <a:spcPts val="150"/>
+              </a:spcBef>
+              <a:defRPr sz="950">
                 <a:solidFill>
                   <a:srgbClr val="F8FAFC"/>
                 </a:solidFill>
@@ -5216,9 +5216,9 @@
           <a:p>
             <a:pPr>
               <a:spcBef>
-                <a:spcPts val="800"/>
-              </a:spcBef>
-              <a:defRPr b="1" sz="1300">
+                <a:spcPts val="500"/>
+              </a:spcBef>
+              <a:defRPr b="1" sz="1100">
                 <a:solidFill>
                   <a:srgbClr val="06B6D4"/>
                 </a:solidFill>
@@ -5231,9 +5231,9 @@
           <a:p>
             <a:pPr>
               <a:spcBef>
-                <a:spcPts val="200"/>
-              </a:spcBef>
-              <a:defRPr sz="1100">
+                <a:spcPts val="150"/>
+              </a:spcBef>
+              <a:defRPr sz="950">
                 <a:solidFill>
                   <a:srgbClr val="F8FAFC"/>
                 </a:solidFill>
@@ -5261,8 +5261,8 @@
         </p:blipFill>
         <p:spPr>
           <a:xfrm>
-            <a:off x="6492240" y="1828800"/>
-            <a:ext cx="4937760" cy="4297680"/>
+            <a:off x="6492240" y="1691640"/>
+            <a:ext cx="4937760" cy="4434840"/>
           </a:xfrm>
           <a:prstGeom prst="rect">
             <a:avLst/>
@@ -5278,7 +5278,7 @@
         <p:spPr>
           <a:xfrm>
             <a:off x="731520" y="6309360"/>
-            <a:ext cx="10728655" cy="365760"/>
+            <a:ext cx="10728655" cy="320040"/>
           </a:xfrm>
           <a:prstGeom prst="rect">
             <a:avLst/>
@@ -5292,14 +5292,14 @@
           <a:lstStyle/>
           <a:p>
             <a:pPr>
-              <a:defRPr sz="900">
+              <a:defRPr sz="850">
                 <a:solidFill>
                   <a:srgbClr val="64748B"/>
                 </a:solidFill>
               </a:defRPr>
             </a:pPr>
             <a:r>
-              <a:t>Google Cloud Hackathon 2026 | Quota Management Control Plane  •  Slide 14 of 17  •  Team: Y. Navaneeth Reddy, Shivam Kumar, Niket Kumar, Allam Sahithi</a:t>
+              <a:t>Google Cloud Hackathon 2026 | Quota Management Control Plane  •  Slide 14 of 17</a:t>
             </a:r>
           </a:p>
         </p:txBody>
@@ -5373,8 +5373,8 @@
         </p:nvSpPr>
         <p:spPr>
           <a:xfrm>
-            <a:off x="731520" y="457200"/>
-            <a:ext cx="4572000" cy="365760"/>
+            <a:off x="731520" y="411480"/>
+            <a:ext cx="5486400" cy="320040"/>
           </a:xfrm>
           <a:prstGeom prst="rect">
             <a:avLst/>
@@ -5388,7 +5388,7 @@
           <a:lstStyle/>
           <a:p>
             <a:pPr>
-              <a:defRPr sz="1000" b="1">
+              <a:defRPr sz="950" b="1">
                 <a:solidFill>
                   <a:srgbClr val="06B6D4"/>
                 </a:solidFill>
@@ -5408,8 +5408,8 @@
         </p:nvSpPr>
         <p:spPr>
           <a:xfrm>
-            <a:off x="731520" y="777240"/>
-            <a:ext cx="10515600" cy="731520"/>
+            <a:off x="731520" y="685800"/>
+            <a:ext cx="10515600" cy="594360"/>
           </a:xfrm>
           <a:prstGeom prst="rect">
             <a:avLst/>
@@ -5423,7 +5423,7 @@
           <a:lstStyle/>
           <a:p>
             <a:pPr>
-              <a:defRPr sz="2200" b="1">
+              <a:defRPr sz="2000" b="1">
                 <a:solidFill>
                   <a:srgbClr val="F8FAFC"/>
                 </a:solidFill>
@@ -5443,7 +5443,7 @@
         </p:nvSpPr>
         <p:spPr>
           <a:xfrm>
-            <a:off x="731520" y="1371600"/>
+            <a:off x="731520" y="1234440"/>
             <a:ext cx="10515600" cy="365760"/>
           </a:xfrm>
           <a:prstGeom prst="rect">
@@ -5458,7 +5458,7 @@
           <a:lstStyle/>
           <a:p>
             <a:pPr>
-              <a:defRPr sz="1200">
+              <a:defRPr sz="1100">
                 <a:solidFill>
                   <a:srgbClr val="94A3B8"/>
                 </a:solidFill>
@@ -5478,8 +5478,8 @@
         </p:nvSpPr>
         <p:spPr>
           <a:xfrm>
-            <a:off x="731520" y="1828800"/>
-            <a:ext cx="5486400" cy="4297680"/>
+            <a:off x="731520" y="1691640"/>
+            <a:ext cx="5486400" cy="4434840"/>
           </a:xfrm>
           <a:prstGeom prst="roundRect">
             <a:avLst/>
@@ -5508,14 +5508,14 @@
           </a:fontRef>
         </p:style>
         <p:txBody>
-          <a:bodyPr rtlCol="0" anchor="ctr" wrap="square" lIns="274320" rIns="274320" tIns="274320"/>
+          <a:bodyPr rtlCol="0" anchor="ctr" wrap="square" lIns="228600" rIns="228600" tIns="228600" bIns="182880"/>
           <a:lstStyle/>
           <a:p>
             <a:pPr algn="ctr">
               <a:spcBef>
                 <a:spcPts val="0"/>
               </a:spcBef>
-              <a:defRPr b="1" sz="1300">
+              <a:defRPr b="1" sz="1100">
                 <a:solidFill>
                   <a:srgbClr val="3B82F6"/>
                 </a:solidFill>
@@ -5528,9 +5528,9 @@
           <a:p>
             <a:pPr>
               <a:spcBef>
-                <a:spcPts val="200"/>
-              </a:spcBef>
-              <a:defRPr sz="1100">
+                <a:spcPts val="150"/>
+              </a:spcBef>
+              <a:defRPr sz="950">
                 <a:solidFill>
                   <a:srgbClr val="F8FAFC"/>
                 </a:solidFill>
@@ -5543,9 +5543,9 @@
           <a:p>
             <a:pPr>
               <a:spcBef>
-                <a:spcPts val="800"/>
-              </a:spcBef>
-              <a:defRPr b="1" sz="1300">
+                <a:spcPts val="500"/>
+              </a:spcBef>
+              <a:defRPr b="1" sz="1100">
                 <a:solidFill>
                   <a:srgbClr val="06B6D4"/>
                 </a:solidFill>
@@ -5558,9 +5558,9 @@
           <a:p>
             <a:pPr>
               <a:spcBef>
-                <a:spcPts val="200"/>
-              </a:spcBef>
-              <a:defRPr sz="1100">
+                <a:spcPts val="150"/>
+              </a:spcBef>
+              <a:defRPr sz="950">
                 <a:solidFill>
                   <a:srgbClr val="F8FAFC"/>
                 </a:solidFill>
@@ -5573,9 +5573,9 @@
           <a:p>
             <a:pPr>
               <a:spcBef>
-                <a:spcPts val="800"/>
-              </a:spcBef>
-              <a:defRPr b="1" sz="1300">
+                <a:spcPts val="500"/>
+              </a:spcBef>
+              <a:defRPr b="1" sz="1100">
                 <a:solidFill>
                   <a:srgbClr val="3B82F6"/>
                 </a:solidFill>
@@ -5588,9 +5588,9 @@
           <a:p>
             <a:pPr>
               <a:spcBef>
-                <a:spcPts val="200"/>
-              </a:spcBef>
-              <a:defRPr sz="1100">
+                <a:spcPts val="150"/>
+              </a:spcBef>
+              <a:defRPr sz="950">
                 <a:solidFill>
                   <a:srgbClr val="F8FAFC"/>
                 </a:solidFill>
@@ -5603,9 +5603,9 @@
           <a:p>
             <a:pPr>
               <a:spcBef>
-                <a:spcPts val="800"/>
-              </a:spcBef>
-              <a:defRPr b="1" sz="1300">
+                <a:spcPts val="500"/>
+              </a:spcBef>
+              <a:defRPr b="1" sz="1100">
                 <a:solidFill>
                   <a:srgbClr val="06B6D4"/>
                 </a:solidFill>
@@ -5618,9 +5618,9 @@
           <a:p>
             <a:pPr>
               <a:spcBef>
-                <a:spcPts val="200"/>
-              </a:spcBef>
-              <a:defRPr sz="1100">
+                <a:spcPts val="150"/>
+              </a:spcBef>
+              <a:defRPr sz="950">
                 <a:solidFill>
                   <a:srgbClr val="F8FAFC"/>
                 </a:solidFill>
@@ -5648,8 +5648,8 @@
         </p:blipFill>
         <p:spPr>
           <a:xfrm>
-            <a:off x="6492240" y="1828800"/>
-            <a:ext cx="4937760" cy="4297680"/>
+            <a:off x="6492240" y="1691640"/>
+            <a:ext cx="4937760" cy="4434840"/>
           </a:xfrm>
           <a:prstGeom prst="rect">
             <a:avLst/>
@@ -5665,7 +5665,7 @@
         <p:spPr>
           <a:xfrm>
             <a:off x="731520" y="6309360"/>
-            <a:ext cx="10728655" cy="365760"/>
+            <a:ext cx="10728655" cy="320040"/>
           </a:xfrm>
           <a:prstGeom prst="rect">
             <a:avLst/>
@@ -5679,14 +5679,14 @@
           <a:lstStyle/>
           <a:p>
             <a:pPr>
-              <a:defRPr sz="900">
+              <a:defRPr sz="850">
                 <a:solidFill>
                   <a:srgbClr val="64748B"/>
                 </a:solidFill>
               </a:defRPr>
             </a:pPr>
             <a:r>
-              <a:t>Google Cloud Hackathon 2026 | Quota Management Control Plane  •  Slide 15 of 17  •  Team: Y. Navaneeth Reddy, Shivam Kumar, Niket Kumar, Allam Sahithi</a:t>
+              <a:t>Google Cloud Hackathon 2026 | Quota Management Control Plane  •  Slide 15 of 17</a:t>
             </a:r>
           </a:p>
         </p:txBody>
@@ -5760,8 +5760,8 @@
         </p:nvSpPr>
         <p:spPr>
           <a:xfrm>
-            <a:off x="731520" y="457200"/>
-            <a:ext cx="4572000" cy="365760"/>
+            <a:off x="731520" y="411480"/>
+            <a:ext cx="5486400" cy="320040"/>
           </a:xfrm>
           <a:prstGeom prst="rect">
             <a:avLst/>
@@ -5775,7 +5775,7 @@
           <a:lstStyle/>
           <a:p>
             <a:pPr>
-              <a:defRPr sz="1000" b="1">
+              <a:defRPr sz="950" b="1">
                 <a:solidFill>
                   <a:srgbClr val="06B6D4"/>
                 </a:solidFill>
@@ -5795,8 +5795,8 @@
         </p:nvSpPr>
         <p:spPr>
           <a:xfrm>
-            <a:off x="731520" y="777240"/>
-            <a:ext cx="10515600" cy="731520"/>
+            <a:off x="731520" y="685800"/>
+            <a:ext cx="10515600" cy="594360"/>
           </a:xfrm>
           <a:prstGeom prst="rect">
             <a:avLst/>
@@ -5810,7 +5810,7 @@
           <a:lstStyle/>
           <a:p>
             <a:pPr>
-              <a:defRPr sz="2200" b="1">
+              <a:defRPr sz="2000" b="1">
                 <a:solidFill>
                   <a:srgbClr val="F8FAFC"/>
                 </a:solidFill>
@@ -5830,7 +5830,7 @@
         </p:nvSpPr>
         <p:spPr>
           <a:xfrm>
-            <a:off x="731520" y="1371600"/>
+            <a:off x="731520" y="1234440"/>
             <a:ext cx="10515600" cy="365760"/>
           </a:xfrm>
           <a:prstGeom prst="rect">
@@ -5845,7 +5845,7 @@
           <a:lstStyle/>
           <a:p>
             <a:pPr>
-              <a:defRPr sz="1200">
+              <a:defRPr sz="1100">
                 <a:solidFill>
                   <a:srgbClr val="94A3B8"/>
                 </a:solidFill>
@@ -5865,8 +5865,8 @@
         </p:nvSpPr>
         <p:spPr>
           <a:xfrm>
-            <a:off x="731520" y="1828800"/>
-            <a:ext cx="5486400" cy="4297680"/>
+            <a:off x="731520" y="1691640"/>
+            <a:ext cx="5486400" cy="4434840"/>
           </a:xfrm>
           <a:prstGeom prst="roundRect">
             <a:avLst/>
@@ -5895,14 +5895,14 @@
           </a:fontRef>
         </p:style>
         <p:txBody>
-          <a:bodyPr rtlCol="0" anchor="ctr" wrap="square" lIns="274320" rIns="274320" tIns="274320"/>
+          <a:bodyPr rtlCol="0" anchor="ctr" wrap="square" lIns="228600" rIns="228600" tIns="228600" bIns="182880"/>
           <a:lstStyle/>
           <a:p>
             <a:pPr algn="ctr">
               <a:spcBef>
                 <a:spcPts val="0"/>
               </a:spcBef>
-              <a:defRPr b="1" sz="1300">
+              <a:defRPr b="1" sz="1100">
                 <a:solidFill>
                   <a:srgbClr val="3B82F6"/>
                 </a:solidFill>
@@ -5915,9 +5915,9 @@
           <a:p>
             <a:pPr>
               <a:spcBef>
-                <a:spcPts val="200"/>
-              </a:spcBef>
-              <a:defRPr sz="1100">
+                <a:spcPts val="150"/>
+              </a:spcBef>
+              <a:defRPr sz="950">
                 <a:solidFill>
                   <a:srgbClr val="F8FAFC"/>
                 </a:solidFill>
@@ -5930,9 +5930,9 @@
           <a:p>
             <a:pPr>
               <a:spcBef>
-                <a:spcPts val="800"/>
-              </a:spcBef>
-              <a:defRPr b="1" sz="1300">
+                <a:spcPts val="500"/>
+              </a:spcBef>
+              <a:defRPr b="1" sz="1100">
                 <a:solidFill>
                   <a:srgbClr val="06B6D4"/>
                 </a:solidFill>
@@ -5945,9 +5945,9 @@
           <a:p>
             <a:pPr>
               <a:spcBef>
-                <a:spcPts val="200"/>
-              </a:spcBef>
-              <a:defRPr sz="1100">
+                <a:spcPts val="150"/>
+              </a:spcBef>
+              <a:defRPr sz="950">
                 <a:solidFill>
                   <a:srgbClr val="F8FAFC"/>
                 </a:solidFill>
@@ -5960,9 +5960,9 @@
           <a:p>
             <a:pPr>
               <a:spcBef>
-                <a:spcPts val="800"/>
-              </a:spcBef>
-              <a:defRPr b="1" sz="1300">
+                <a:spcPts val="500"/>
+              </a:spcBef>
+              <a:defRPr b="1" sz="1100">
                 <a:solidFill>
                   <a:srgbClr val="3B82F6"/>
                 </a:solidFill>
@@ -5975,9 +5975,9 @@
           <a:p>
             <a:pPr>
               <a:spcBef>
-                <a:spcPts val="200"/>
-              </a:spcBef>
-              <a:defRPr sz="1100">
+                <a:spcPts val="150"/>
+              </a:spcBef>
+              <a:defRPr sz="950">
                 <a:solidFill>
                   <a:srgbClr val="F8FAFC"/>
                 </a:solidFill>
@@ -5990,9 +5990,9 @@
           <a:p>
             <a:pPr>
               <a:spcBef>
-                <a:spcPts val="800"/>
-              </a:spcBef>
-              <a:defRPr b="1" sz="1300">
+                <a:spcPts val="500"/>
+              </a:spcBef>
+              <a:defRPr b="1" sz="1100">
                 <a:solidFill>
                   <a:srgbClr val="06B6D4"/>
                 </a:solidFill>
@@ -6005,9 +6005,9 @@
           <a:p>
             <a:pPr>
               <a:spcBef>
-                <a:spcPts val="200"/>
-              </a:spcBef>
-              <a:defRPr sz="1100">
+                <a:spcPts val="150"/>
+              </a:spcBef>
+              <a:defRPr sz="950">
                 <a:solidFill>
                   <a:srgbClr val="F8FAFC"/>
                 </a:solidFill>
@@ -6035,8 +6035,8 @@
         </p:blipFill>
         <p:spPr>
           <a:xfrm>
-            <a:off x="6492240" y="1828800"/>
-            <a:ext cx="4937760" cy="4297680"/>
+            <a:off x="6492240" y="1691640"/>
+            <a:ext cx="4937760" cy="4434840"/>
           </a:xfrm>
           <a:prstGeom prst="rect">
             <a:avLst/>
@@ -6052,7 +6052,7 @@
         <p:spPr>
           <a:xfrm>
             <a:off x="731520" y="6309360"/>
-            <a:ext cx="10728655" cy="365760"/>
+            <a:ext cx="10728655" cy="320040"/>
           </a:xfrm>
           <a:prstGeom prst="rect">
             <a:avLst/>
@@ -6066,14 +6066,14 @@
           <a:lstStyle/>
           <a:p>
             <a:pPr>
-              <a:defRPr sz="900">
+              <a:defRPr sz="850">
                 <a:solidFill>
                   <a:srgbClr val="64748B"/>
                 </a:solidFill>
               </a:defRPr>
             </a:pPr>
             <a:r>
-              <a:t>Google Cloud Hackathon 2026 | Quota Management Control Plane  •  Slide 16 of 17  •  Team: Y. Navaneeth Reddy, Shivam Kumar, Niket Kumar, Allam Sahithi</a:t>
+              <a:t>Google Cloud Hackathon 2026 | Quota Management Control Plane  •  Slide 16 of 17</a:t>
             </a:r>
           </a:p>
         </p:txBody>
@@ -6156,7 +6156,7 @@
           <a:solidFill>
             <a:srgbClr val="1E293B"/>
           </a:solidFill>
-          <a:ln w="25400">
+          <a:ln w="19050">
             <a:solidFill>
               <a:srgbClr val="10B981"/>
             </a:solidFill>
@@ -6177,11 +6177,11 @@
           </a:fontRef>
         </p:style>
         <p:txBody>
-          <a:bodyPr rtlCol="0" anchor="ctr" wrap="square" lIns="365760" rIns="365760" tIns="365760"/>
+          <a:bodyPr rtlCol="0" anchor="ctr" wrap="square" lIns="320040" rIns="320040" tIns="320040"/>
           <a:lstStyle/>
           <a:p>
             <a:pPr algn="ctr">
-              <a:defRPr sz="1100" b="1">
+              <a:defRPr sz="1000" b="1">
                 <a:solidFill>
                   <a:srgbClr val="10B981"/>
                 </a:solidFill>
@@ -6194,9 +6194,9 @@
           <a:p>
             <a:pPr>
               <a:spcBef>
-                <a:spcPts val="800"/>
-              </a:spcBef>
-              <a:defRPr sz="2400" b="1">
+                <a:spcPts val="600"/>
+              </a:spcBef>
+              <a:defRPr sz="2200" b="1">
                 <a:solidFill>
                   <a:srgbClr val="F8FAFC"/>
                 </a:solidFill>
@@ -6209,9 +6209,9 @@
           <a:p>
             <a:pPr>
               <a:spcBef>
-                <a:spcPts val="800"/>
-              </a:spcBef>
-              <a:defRPr sz="1100">
+                <a:spcPts val="600"/>
+              </a:spcBef>
+              <a:defRPr sz="1000">
                 <a:solidFill>
                   <a:srgbClr val="94A3B8"/>
                 </a:solidFill>
@@ -6226,7 +6226,7 @@
               <a:spcBef>
                 <a:spcPts val="300"/>
               </a:spcBef>
-              <a:defRPr sz="1000">
+              <a:defRPr sz="950">
                 <a:solidFill>
                   <a:srgbClr val="F8FAFC"/>
                 </a:solidFill>
@@ -6241,7 +6241,7 @@
               <a:spcBef>
                 <a:spcPts val="300"/>
               </a:spcBef>
-              <a:defRPr sz="1000">
+              <a:defRPr sz="950">
                 <a:solidFill>
                   <a:srgbClr val="F8FAFC"/>
                 </a:solidFill>
@@ -6256,7 +6256,7 @@
               <a:spcBef>
                 <a:spcPts val="300"/>
               </a:spcBef>
-              <a:defRPr sz="1000">
+              <a:defRPr sz="950">
                 <a:solidFill>
                   <a:srgbClr val="F8FAFC"/>
                 </a:solidFill>
@@ -6271,7 +6271,7 @@
               <a:spcBef>
                 <a:spcPts val="300"/>
               </a:spcBef>
-              <a:defRPr sz="1000">
+              <a:defRPr sz="950">
                 <a:solidFill>
                   <a:srgbClr val="F8FAFC"/>
                 </a:solidFill>
@@ -6286,7 +6286,7 @@
               <a:spcBef>
                 <a:spcPts val="300"/>
               </a:spcBef>
-              <a:defRPr sz="1000">
+              <a:defRPr sz="950">
                 <a:solidFill>
                   <a:srgbClr val="F8FAFC"/>
                 </a:solidFill>
@@ -6301,7 +6301,7 @@
               <a:spcBef>
                 <a:spcPts val="300"/>
               </a:spcBef>
-              <a:defRPr sz="1000">
+              <a:defRPr sz="950">
                 <a:solidFill>
                   <a:srgbClr val="F8FAFC"/>
                 </a:solidFill>
@@ -6314,9 +6314,9 @@
           <a:p>
             <a:pPr>
               <a:spcBef>
-                <a:spcPts val="1600"/>
-              </a:spcBef>
-              <a:defRPr sz="1300" b="1">
+                <a:spcPts val="1400"/>
+              </a:spcBef>
+              <a:defRPr sz="1200" b="1">
                 <a:solidFill>
                   <a:srgbClr val="06B6D4"/>
                 </a:solidFill>
@@ -6361,7 +6361,7 @@
         <p:spPr>
           <a:xfrm>
             <a:off x="731520" y="6309360"/>
-            <a:ext cx="10728655" cy="365760"/>
+            <a:ext cx="10728655" cy="320040"/>
           </a:xfrm>
           <a:prstGeom prst="rect">
             <a:avLst/>
@@ -6375,14 +6375,14 @@
           <a:lstStyle/>
           <a:p>
             <a:pPr>
-              <a:defRPr sz="900">
+              <a:defRPr sz="850">
                 <a:solidFill>
                   <a:srgbClr val="64748B"/>
                 </a:solidFill>
               </a:defRPr>
             </a:pPr>
             <a:r>
-              <a:t>Google Cloud Hackathon 2026 | Quota Management Control Plane  •  Slide 17 of 17  •  Team: Y. Navaneeth Reddy, Shivam Kumar, Niket Kumar, Allam Sahithi</a:t>
+              <a:t>Google Cloud Hackathon 2026 | Quota Management Control Plane  •  Slide 17 of 17</a:t>
             </a:r>
           </a:p>
         </p:txBody>
@@ -6456,8 +6456,8 @@
         </p:nvSpPr>
         <p:spPr>
           <a:xfrm>
-            <a:off x="731520" y="457200"/>
-            <a:ext cx="4572000" cy="365760"/>
+            <a:off x="731520" y="411480"/>
+            <a:ext cx="5486400" cy="320040"/>
           </a:xfrm>
           <a:prstGeom prst="rect">
             <a:avLst/>
@@ -6471,14 +6471,14 @@
           <a:lstStyle/>
           <a:p>
             <a:pPr>
-              <a:defRPr sz="1000" b="1">
+              <a:defRPr sz="950" b="1">
                 <a:solidFill>
                   <a:srgbClr val="06B6D4"/>
                 </a:solidFill>
               </a:defRPr>
             </a:pPr>
             <a:r>
-              <a:t>CORE ENGINEERING TEAM</a:t>
+              <a:t>PROJECT TEAM</a:t>
             </a:r>
           </a:p>
         </p:txBody>
@@ -6491,8 +6491,8 @@
         </p:nvSpPr>
         <p:spPr>
           <a:xfrm>
-            <a:off x="731520" y="777240"/>
-            <a:ext cx="10515600" cy="731520"/>
+            <a:off x="731520" y="685800"/>
+            <a:ext cx="10515600" cy="594360"/>
           </a:xfrm>
           <a:prstGeom prst="rect">
             <a:avLst/>
@@ -6506,14 +6506,14 @@
           <a:lstStyle/>
           <a:p>
             <a:pPr>
-              <a:defRPr sz="2200" b="1">
+              <a:defRPr sz="2000" b="1">
                 <a:solidFill>
                   <a:srgbClr val="F8FAFC"/>
                 </a:solidFill>
               </a:defRPr>
             </a:pPr>
             <a:r>
-              <a:t>Project Team Roster &amp; Architectural Responsibilities</a:t>
+              <a:t>Engineering Team &amp; Student Roster</a:t>
             </a:r>
           </a:p>
         </p:txBody>
@@ -6526,7 +6526,7 @@
         </p:nvSpPr>
         <p:spPr>
           <a:xfrm>
-            <a:off x="731520" y="1371600"/>
+            <a:off x="731520" y="1234440"/>
             <a:ext cx="10515600" cy="365760"/>
           </a:xfrm>
           <a:prstGeom prst="rect">
@@ -6541,14 +6541,14 @@
           <a:lstStyle/>
           <a:p>
             <a:pPr>
-              <a:defRPr sz="1200">
+              <a:defRPr sz="1100">
                 <a:solidFill>
                   <a:srgbClr val="94A3B8"/>
                 </a:solidFill>
               </a:defRPr>
             </a:pPr>
             <a:r>
-              <a:t>Specialized cross-functional engineering contributions across the full stack.</a:t>
+              <a:t>Collaborative development team for Google Cloud Hackathon 2026.</a:t>
             </a:r>
           </a:p>
         </p:txBody>
@@ -6561,8 +6561,8 @@
         </p:nvSpPr>
         <p:spPr>
           <a:xfrm>
-            <a:off x="731520" y="1828800"/>
-            <a:ext cx="5486400" cy="4297680"/>
+            <a:off x="731520" y="1691640"/>
+            <a:ext cx="5486400" cy="4434840"/>
           </a:xfrm>
           <a:prstGeom prst="roundRect">
             <a:avLst/>
@@ -6591,126 +6591,126 @@
           </a:fontRef>
         </p:style>
         <p:txBody>
-          <a:bodyPr rtlCol="0" anchor="ctr" wrap="square" lIns="274320" rIns="274320" tIns="274320"/>
+          <a:bodyPr rtlCol="0" anchor="ctr" wrap="square" lIns="228600" rIns="228600" tIns="228600" bIns="182880"/>
           <a:lstStyle/>
           <a:p>
             <a:pPr algn="ctr">
               <a:spcBef>
                 <a:spcPts val="0"/>
               </a:spcBef>
-              <a:defRPr b="1" sz="1300">
+              <a:defRPr b="1" sz="1100">
                 <a:solidFill>
                   <a:srgbClr val="3B82F6"/>
                 </a:solidFill>
               </a:defRPr>
             </a:pPr>
             <a:r>
-              <a:t>•  Yadamakanti Navaneeth Reddy (2400030020)</a:t>
-            </a:r>
-          </a:p>
-          <a:p>
-            <a:pPr>
-              <a:spcBef>
-                <a:spcPts val="200"/>
-              </a:spcBef>
-              <a:defRPr sz="1100">
+              <a:t>•  YADAMAKANTI NAVANEETH REDDY</a:t>
+            </a:r>
+          </a:p>
+          <a:p>
+            <a:pPr>
+              <a:spcBef>
+                <a:spcPts val="150"/>
+              </a:spcBef>
+              <a:defRPr sz="950">
                 <a:solidFill>
                   <a:srgbClr val="F8FAFC"/>
                 </a:solidFill>
               </a:defRPr>
             </a:pPr>
             <a:r>
-              <a:t>    Lead Cloud Architect &amp; Full-Stack Lead: Designed core architecture, state machine workflow, and end-to-end GCP integration.</a:t>
-            </a:r>
-          </a:p>
-          <a:p>
-            <a:pPr>
-              <a:spcBef>
-                <a:spcPts val="800"/>
-              </a:spcBef>
-              <a:defRPr b="1" sz="1300">
+              <a:t>    Registration Number: 2400030020</a:t>
+            </a:r>
+          </a:p>
+          <a:p>
+            <a:pPr>
+              <a:spcBef>
+                <a:spcPts val="500"/>
+              </a:spcBef>
+              <a:defRPr b="1" sz="1100">
                 <a:solidFill>
                   <a:srgbClr val="06B6D4"/>
                 </a:solidFill>
               </a:defRPr>
             </a:pPr>
             <a:r>
-              <a:t>•  Shivam Kumar Saw (2400039056)</a:t>
-            </a:r>
-          </a:p>
-          <a:p>
-            <a:pPr>
-              <a:spcBef>
-                <a:spcPts val="200"/>
-              </a:spcBef>
-              <a:defRPr sz="1100">
+              <a:t>•  SHIVAM KUMAR SAW</a:t>
+            </a:r>
+          </a:p>
+          <a:p>
+            <a:pPr>
+              <a:spcBef>
+                <a:spcPts val="150"/>
+              </a:spcBef>
+              <a:defRPr sz="950">
                 <a:solidFill>
                   <a:srgbClr val="F8FAFC"/>
                 </a:solidFill>
               </a:defRPr>
             </a:pPr>
             <a:r>
-              <a:t>    Backend &amp; API Integration Specialist: Built Express REST gateway, Zod validation schemas, Morgan logging, and error handling layers.</a:t>
-            </a:r>
-          </a:p>
-          <a:p>
-            <a:pPr>
-              <a:spcBef>
-                <a:spcPts val="800"/>
-              </a:spcBef>
-              <a:defRPr b="1" sz="1300">
+              <a:t>    Registration Number: 2400039056</a:t>
+            </a:r>
+          </a:p>
+          <a:p>
+            <a:pPr>
+              <a:spcBef>
+                <a:spcPts val="500"/>
+              </a:spcBef>
+              <a:defRPr b="1" sz="1100">
                 <a:solidFill>
                   <a:srgbClr val="3B82F6"/>
                 </a:solidFill>
               </a:defRPr>
             </a:pPr>
             <a:r>
-              <a:t>•  Niket Kumar (2400033292)</a:t>
-            </a:r>
-          </a:p>
-          <a:p>
-            <a:pPr>
-              <a:spcBef>
-                <a:spcPts val="200"/>
-              </a:spcBef>
-              <a:defRPr sz="1100">
+              <a:t>•  NIKET KUMAR</a:t>
+            </a:r>
+          </a:p>
+          <a:p>
+            <a:pPr>
+              <a:spcBef>
+                <a:spcPts val="150"/>
+              </a:spcBef>
+              <a:defRPr sz="950">
                 <a:solidFill>
                   <a:srgbClr val="F8FAFC"/>
                 </a:solidFill>
               </a:defRPr>
             </a:pPr>
             <a:r>
-              <a:t>    DevOps &amp; Cloud Infrastructure Lead: Provisioned Terraform IaC, Docker multi-stage containers, GitHub Actions CI/CD, and Cloud Build.</a:t>
-            </a:r>
-          </a:p>
-          <a:p>
-            <a:pPr>
-              <a:spcBef>
-                <a:spcPts val="800"/>
-              </a:spcBef>
-              <a:defRPr b="1" sz="1300">
+              <a:t>    Registration Number: 2400033292</a:t>
+            </a:r>
+          </a:p>
+          <a:p>
+            <a:pPr>
+              <a:spcBef>
+                <a:spcPts val="500"/>
+              </a:spcBef>
+              <a:defRPr b="1" sz="1100">
                 <a:solidFill>
                   <a:srgbClr val="06B6D4"/>
                 </a:solidFill>
               </a:defRPr>
             </a:pPr>
             <a:r>
-              <a:t>•  Allam Sahithi (2400033195)</a:t>
-            </a:r>
-          </a:p>
-          <a:p>
-            <a:pPr>
-              <a:spcBef>
-                <a:spcPts val="200"/>
-              </a:spcBef>
-              <a:defRPr sz="1100">
+              <a:t>•  ALLAM SAHITHI</a:t>
+            </a:r>
+          </a:p>
+          <a:p>
+            <a:pPr>
+              <a:spcBef>
+                <a:spcPts val="150"/>
+              </a:spcBef>
+              <a:defRPr sz="950">
                 <a:solidFill>
                   <a:srgbClr val="F8FAFC"/>
                 </a:solidFill>
               </a:defRPr>
             </a:pPr>
             <a:r>
-              <a:t>    Frontend UX &amp; Testing Engineer: Implemented Tailwind design system, WCAG 2.1 AA accessibility, and automated Jest test suites.</a:t>
+              <a:t>    Registration Number: 2400033195</a:t>
             </a:r>
           </a:p>
         </p:txBody>
@@ -6731,8 +6731,8 @@
         </p:blipFill>
         <p:spPr>
           <a:xfrm>
-            <a:off x="6492240" y="1828800"/>
-            <a:ext cx="4937760" cy="4297680"/>
+            <a:off x="6492240" y="1691640"/>
+            <a:ext cx="4937760" cy="4434840"/>
           </a:xfrm>
           <a:prstGeom prst="rect">
             <a:avLst/>
@@ -6748,7 +6748,7 @@
         <p:spPr>
           <a:xfrm>
             <a:off x="731520" y="6309360"/>
-            <a:ext cx="10728655" cy="365760"/>
+            <a:ext cx="10728655" cy="320040"/>
           </a:xfrm>
           <a:prstGeom prst="rect">
             <a:avLst/>
@@ -6762,14 +6762,14 @@
           <a:lstStyle/>
           <a:p>
             <a:pPr>
-              <a:defRPr sz="900">
+              <a:defRPr sz="850">
                 <a:solidFill>
                   <a:srgbClr val="64748B"/>
                 </a:solidFill>
               </a:defRPr>
             </a:pPr>
             <a:r>
-              <a:t>Google Cloud Hackathon 2026 | Quota Management Control Plane  •  Slide 2 of 17  •  Team: Y. Navaneeth Reddy, Shivam Kumar, Niket Kumar, Allam Sahithi</a:t>
+              <a:t>Google Cloud Hackathon 2026 | Quota Management Control Plane  •  Slide 2 of 17</a:t>
             </a:r>
           </a:p>
         </p:txBody>
@@ -6843,8 +6843,8 @@
         </p:nvSpPr>
         <p:spPr>
           <a:xfrm>
-            <a:off x="731520" y="457200"/>
-            <a:ext cx="4572000" cy="365760"/>
+            <a:off x="731520" y="411480"/>
+            <a:ext cx="5486400" cy="320040"/>
           </a:xfrm>
           <a:prstGeom prst="rect">
             <a:avLst/>
@@ -6858,7 +6858,7 @@
           <a:lstStyle/>
           <a:p>
             <a:pPr>
-              <a:defRPr sz="1000" b="1">
+              <a:defRPr sz="950" b="1">
                 <a:solidFill>
                   <a:srgbClr val="06B6D4"/>
                 </a:solidFill>
@@ -6878,8 +6878,8 @@
         </p:nvSpPr>
         <p:spPr>
           <a:xfrm>
-            <a:off x="731520" y="777240"/>
-            <a:ext cx="10515600" cy="731520"/>
+            <a:off x="731520" y="685800"/>
+            <a:ext cx="10515600" cy="594360"/>
           </a:xfrm>
           <a:prstGeom prst="rect">
             <a:avLst/>
@@ -6893,7 +6893,7 @@
           <a:lstStyle/>
           <a:p>
             <a:pPr>
-              <a:defRPr sz="2200" b="1">
+              <a:defRPr sz="2000" b="1">
                 <a:solidFill>
                   <a:srgbClr val="F8FAFC"/>
                 </a:solidFill>
@@ -6913,7 +6913,7 @@
         </p:nvSpPr>
         <p:spPr>
           <a:xfrm>
-            <a:off x="731520" y="1371600"/>
+            <a:off x="731520" y="1234440"/>
             <a:ext cx="10515600" cy="365760"/>
           </a:xfrm>
           <a:prstGeom prst="rect">
@@ -6928,7 +6928,7 @@
           <a:lstStyle/>
           <a:p>
             <a:pPr>
-              <a:defRPr sz="1200">
+              <a:defRPr sz="1100">
                 <a:solidFill>
                   <a:srgbClr val="94A3B8"/>
                 </a:solidFill>
@@ -6948,8 +6948,8 @@
         </p:nvSpPr>
         <p:spPr>
           <a:xfrm>
-            <a:off x="731520" y="1828800"/>
-            <a:ext cx="5486400" cy="4297680"/>
+            <a:off x="731520" y="1691640"/>
+            <a:ext cx="5486400" cy="4434840"/>
           </a:xfrm>
           <a:prstGeom prst="roundRect">
             <a:avLst/>
@@ -6978,14 +6978,14 @@
           </a:fontRef>
         </p:style>
         <p:txBody>
-          <a:bodyPr rtlCol="0" anchor="ctr" wrap="square" lIns="274320" rIns="274320" tIns="274320"/>
+          <a:bodyPr rtlCol="0" anchor="ctr" wrap="square" lIns="228600" rIns="228600" tIns="228600" bIns="182880"/>
           <a:lstStyle/>
           <a:p>
             <a:pPr algn="ctr">
               <a:spcBef>
                 <a:spcPts val="0"/>
               </a:spcBef>
-              <a:defRPr b="1" sz="1300">
+              <a:defRPr b="1" sz="1100">
                 <a:solidFill>
                   <a:srgbClr val="3B82F6"/>
                 </a:solidFill>
@@ -6998,9 +6998,9 @@
           <a:p>
             <a:pPr>
               <a:spcBef>
-                <a:spcPts val="200"/>
-              </a:spcBef>
-              <a:defRPr sz="1100">
+                <a:spcPts val="150"/>
+              </a:spcBef>
+              <a:defRPr sz="950">
                 <a:solidFill>
                   <a:srgbClr val="F8FAFC"/>
                 </a:solidFill>
@@ -7013,9 +7013,9 @@
           <a:p>
             <a:pPr>
               <a:spcBef>
-                <a:spcPts val="800"/>
-              </a:spcBef>
-              <a:defRPr b="1" sz="1300">
+                <a:spcPts val="500"/>
+              </a:spcBef>
+              <a:defRPr b="1" sz="1100">
                 <a:solidFill>
                   <a:srgbClr val="06B6D4"/>
                 </a:solidFill>
@@ -7028,9 +7028,9 @@
           <a:p>
             <a:pPr>
               <a:spcBef>
-                <a:spcPts val="200"/>
-              </a:spcBef>
-              <a:defRPr sz="1100">
+                <a:spcPts val="150"/>
+              </a:spcBef>
+              <a:defRPr sz="950">
                 <a:solidFill>
                   <a:srgbClr val="F8FAFC"/>
                 </a:solidFill>
@@ -7043,9 +7043,9 @@
           <a:p>
             <a:pPr>
               <a:spcBef>
-                <a:spcPts val="800"/>
-              </a:spcBef>
-              <a:defRPr b="1" sz="1300">
+                <a:spcPts val="500"/>
+              </a:spcBef>
+              <a:defRPr b="1" sz="1100">
                 <a:solidFill>
                   <a:srgbClr val="3B82F6"/>
                 </a:solidFill>
@@ -7058,9 +7058,9 @@
           <a:p>
             <a:pPr>
               <a:spcBef>
-                <a:spcPts val="200"/>
-              </a:spcBef>
-              <a:defRPr sz="1100">
+                <a:spcPts val="150"/>
+              </a:spcBef>
+              <a:defRPr sz="950">
                 <a:solidFill>
                   <a:srgbClr val="F8FAFC"/>
                 </a:solidFill>
@@ -7073,9 +7073,9 @@
           <a:p>
             <a:pPr>
               <a:spcBef>
-                <a:spcPts val="800"/>
-              </a:spcBef>
-              <a:defRPr b="1" sz="1300">
+                <a:spcPts val="500"/>
+              </a:spcBef>
+              <a:defRPr b="1" sz="1100">
                 <a:solidFill>
                   <a:srgbClr val="06B6D4"/>
                 </a:solidFill>
@@ -7088,9 +7088,9 @@
           <a:p>
             <a:pPr>
               <a:spcBef>
-                <a:spcPts val="200"/>
-              </a:spcBef>
-              <a:defRPr sz="1100">
+                <a:spcPts val="150"/>
+              </a:spcBef>
+              <a:defRPr sz="950">
                 <a:solidFill>
                   <a:srgbClr val="F8FAFC"/>
                 </a:solidFill>
@@ -7118,8 +7118,8 @@
         </p:blipFill>
         <p:spPr>
           <a:xfrm>
-            <a:off x="6492240" y="1828800"/>
-            <a:ext cx="4937760" cy="4297680"/>
+            <a:off x="6492240" y="1691640"/>
+            <a:ext cx="4937760" cy="4434840"/>
           </a:xfrm>
           <a:prstGeom prst="rect">
             <a:avLst/>
@@ -7135,7 +7135,7 @@
         <p:spPr>
           <a:xfrm>
             <a:off x="731520" y="6309360"/>
-            <a:ext cx="10728655" cy="365760"/>
+            <a:ext cx="10728655" cy="320040"/>
           </a:xfrm>
           <a:prstGeom prst="rect">
             <a:avLst/>
@@ -7149,14 +7149,14 @@
           <a:lstStyle/>
           <a:p>
             <a:pPr>
-              <a:defRPr sz="900">
+              <a:defRPr sz="850">
                 <a:solidFill>
                   <a:srgbClr val="64748B"/>
                 </a:solidFill>
               </a:defRPr>
             </a:pPr>
             <a:r>
-              <a:t>Google Cloud Hackathon 2026 | Quota Management Control Plane  •  Slide 3 of 17  •  Team: Y. Navaneeth Reddy, Shivam Kumar, Niket Kumar, Allam Sahithi</a:t>
+              <a:t>Google Cloud Hackathon 2026 | Quota Management Control Plane  •  Slide 3 of 17</a:t>
             </a:r>
           </a:p>
         </p:txBody>
@@ -7230,8 +7230,8 @@
         </p:nvSpPr>
         <p:spPr>
           <a:xfrm>
-            <a:off x="731520" y="457200"/>
-            <a:ext cx="4572000" cy="365760"/>
+            <a:off x="731520" y="411480"/>
+            <a:ext cx="5486400" cy="320040"/>
           </a:xfrm>
           <a:prstGeom prst="rect">
             <a:avLst/>
@@ -7245,7 +7245,7 @@
           <a:lstStyle/>
           <a:p>
             <a:pPr>
-              <a:defRPr sz="1000" b="1">
+              <a:defRPr sz="950" b="1">
                 <a:solidFill>
                   <a:srgbClr val="06B6D4"/>
                 </a:solidFill>
@@ -7265,8 +7265,8 @@
         </p:nvSpPr>
         <p:spPr>
           <a:xfrm>
-            <a:off x="731520" y="777240"/>
-            <a:ext cx="10515600" cy="731520"/>
+            <a:off x="731520" y="685800"/>
+            <a:ext cx="10515600" cy="594360"/>
           </a:xfrm>
           <a:prstGeom prst="rect">
             <a:avLst/>
@@ -7280,7 +7280,7 @@
           <a:lstStyle/>
           <a:p>
             <a:pPr>
-              <a:defRPr sz="2200" b="1">
+              <a:defRPr sz="2000" b="1">
                 <a:solidFill>
                   <a:srgbClr val="F8FAFC"/>
                 </a:solidFill>
@@ -7300,7 +7300,7 @@
         </p:nvSpPr>
         <p:spPr>
           <a:xfrm>
-            <a:off x="731520" y="1371600"/>
+            <a:off x="731520" y="1234440"/>
             <a:ext cx="10515600" cy="365760"/>
           </a:xfrm>
           <a:prstGeom prst="rect">
@@ -7315,7 +7315,7 @@
           <a:lstStyle/>
           <a:p>
             <a:pPr>
-              <a:defRPr sz="1200">
+              <a:defRPr sz="1100">
                 <a:solidFill>
                   <a:srgbClr val="94A3B8"/>
                 </a:solidFill>
@@ -7335,8 +7335,8 @@
         </p:nvSpPr>
         <p:spPr>
           <a:xfrm>
-            <a:off x="731520" y="1828800"/>
-            <a:ext cx="5486400" cy="4297680"/>
+            <a:off x="731520" y="1691640"/>
+            <a:ext cx="5486400" cy="4434840"/>
           </a:xfrm>
           <a:prstGeom prst="roundRect">
             <a:avLst/>
@@ -7365,14 +7365,14 @@
           </a:fontRef>
         </p:style>
         <p:txBody>
-          <a:bodyPr rtlCol="0" anchor="ctr" wrap="square" lIns="274320" rIns="274320" tIns="274320"/>
+          <a:bodyPr rtlCol="0" anchor="ctr" wrap="square" lIns="228600" rIns="228600" tIns="228600" bIns="182880"/>
           <a:lstStyle/>
           <a:p>
             <a:pPr algn="ctr">
               <a:spcBef>
                 <a:spcPts val="0"/>
               </a:spcBef>
-              <a:defRPr b="1" sz="1300">
+              <a:defRPr b="1" sz="1100">
                 <a:solidFill>
                   <a:srgbClr val="3B82F6"/>
                 </a:solidFill>
@@ -7385,9 +7385,9 @@
           <a:p>
             <a:pPr>
               <a:spcBef>
-                <a:spcPts val="200"/>
-              </a:spcBef>
-              <a:defRPr sz="1100">
+                <a:spcPts val="150"/>
+              </a:spcBef>
+              <a:defRPr sz="950">
                 <a:solidFill>
                   <a:srgbClr val="F8FAFC"/>
                 </a:solidFill>
@@ -7400,9 +7400,9 @@
           <a:p>
             <a:pPr>
               <a:spcBef>
-                <a:spcPts val="800"/>
-              </a:spcBef>
-              <a:defRPr b="1" sz="1300">
+                <a:spcPts val="500"/>
+              </a:spcBef>
+              <a:defRPr b="1" sz="1100">
                 <a:solidFill>
                   <a:srgbClr val="06B6D4"/>
                 </a:solidFill>
@@ -7415,9 +7415,9 @@
           <a:p>
             <a:pPr>
               <a:spcBef>
-                <a:spcPts val="200"/>
-              </a:spcBef>
-              <a:defRPr sz="1100">
+                <a:spcPts val="150"/>
+              </a:spcBef>
+              <a:defRPr sz="950">
                 <a:solidFill>
                   <a:srgbClr val="F8FAFC"/>
                 </a:solidFill>
@@ -7430,9 +7430,9 @@
           <a:p>
             <a:pPr>
               <a:spcBef>
-                <a:spcPts val="800"/>
-              </a:spcBef>
-              <a:defRPr b="1" sz="1300">
+                <a:spcPts val="500"/>
+              </a:spcBef>
+              <a:defRPr b="1" sz="1100">
                 <a:solidFill>
                   <a:srgbClr val="3B82F6"/>
                 </a:solidFill>
@@ -7445,9 +7445,9 @@
           <a:p>
             <a:pPr>
               <a:spcBef>
-                <a:spcPts val="200"/>
-              </a:spcBef>
-              <a:defRPr sz="1100">
+                <a:spcPts val="150"/>
+              </a:spcBef>
+              <a:defRPr sz="950">
                 <a:solidFill>
                   <a:srgbClr val="F8FAFC"/>
                 </a:solidFill>
@@ -7460,9 +7460,9 @@
           <a:p>
             <a:pPr>
               <a:spcBef>
-                <a:spcPts val="800"/>
-              </a:spcBef>
-              <a:defRPr b="1" sz="1300">
+                <a:spcPts val="500"/>
+              </a:spcBef>
+              <a:defRPr b="1" sz="1100">
                 <a:solidFill>
                   <a:srgbClr val="06B6D4"/>
                 </a:solidFill>
@@ -7475,9 +7475,9 @@
           <a:p>
             <a:pPr>
               <a:spcBef>
-                <a:spcPts val="200"/>
-              </a:spcBef>
-              <a:defRPr sz="1100">
+                <a:spcPts val="150"/>
+              </a:spcBef>
+              <a:defRPr sz="950">
                 <a:solidFill>
                   <a:srgbClr val="F8FAFC"/>
                 </a:solidFill>
@@ -7505,8 +7505,8 @@
         </p:blipFill>
         <p:spPr>
           <a:xfrm>
-            <a:off x="6492240" y="1828800"/>
-            <a:ext cx="4937760" cy="4297680"/>
+            <a:off x="6492240" y="1691640"/>
+            <a:ext cx="4937760" cy="4434840"/>
           </a:xfrm>
           <a:prstGeom prst="rect">
             <a:avLst/>
@@ -7522,7 +7522,7 @@
         <p:spPr>
           <a:xfrm>
             <a:off x="731520" y="6309360"/>
-            <a:ext cx="10728655" cy="365760"/>
+            <a:ext cx="10728655" cy="320040"/>
           </a:xfrm>
           <a:prstGeom prst="rect">
             <a:avLst/>
@@ -7536,14 +7536,14 @@
           <a:lstStyle/>
           <a:p>
             <a:pPr>
-              <a:defRPr sz="900">
+              <a:defRPr sz="850">
                 <a:solidFill>
                   <a:srgbClr val="64748B"/>
                 </a:solidFill>
               </a:defRPr>
             </a:pPr>
             <a:r>
-              <a:t>Google Cloud Hackathon 2026 | Quota Management Control Plane  •  Slide 4 of 17  •  Team: Y. Navaneeth Reddy, Shivam Kumar, Niket Kumar, Allam Sahithi</a:t>
+              <a:t>Google Cloud Hackathon 2026 | Quota Management Control Plane  •  Slide 4 of 17</a:t>
             </a:r>
           </a:p>
         </p:txBody>
@@ -7617,8 +7617,8 @@
         </p:nvSpPr>
         <p:spPr>
           <a:xfrm>
-            <a:off x="731520" y="457200"/>
-            <a:ext cx="4572000" cy="365760"/>
+            <a:off x="731520" y="411480"/>
+            <a:ext cx="5486400" cy="320040"/>
           </a:xfrm>
           <a:prstGeom prst="rect">
             <a:avLst/>
@@ -7632,7 +7632,7 @@
           <a:lstStyle/>
           <a:p>
             <a:pPr>
-              <a:defRPr sz="1000" b="1">
+              <a:defRPr sz="950" b="1">
                 <a:solidFill>
                   <a:srgbClr val="06B6D4"/>
                 </a:solidFill>
@@ -7652,8 +7652,8 @@
         </p:nvSpPr>
         <p:spPr>
           <a:xfrm>
-            <a:off x="731520" y="777240"/>
-            <a:ext cx="10515600" cy="731520"/>
+            <a:off x="731520" y="685800"/>
+            <a:ext cx="10515600" cy="594360"/>
           </a:xfrm>
           <a:prstGeom prst="rect">
             <a:avLst/>
@@ -7667,7 +7667,7 @@
           <a:lstStyle/>
           <a:p>
             <a:pPr>
-              <a:defRPr sz="2200" b="1">
+              <a:defRPr sz="2000" b="1">
                 <a:solidFill>
                   <a:srgbClr val="F8FAFC"/>
                 </a:solidFill>
@@ -7687,7 +7687,7 @@
         </p:nvSpPr>
         <p:spPr>
           <a:xfrm>
-            <a:off x="731520" y="1371600"/>
+            <a:off x="731520" y="1234440"/>
             <a:ext cx="10515600" cy="365760"/>
           </a:xfrm>
           <a:prstGeom prst="rect">
@@ -7702,7 +7702,7 @@
           <a:lstStyle/>
           <a:p>
             <a:pPr>
-              <a:defRPr sz="1200">
+              <a:defRPr sz="1100">
                 <a:solidFill>
                   <a:srgbClr val="94A3B8"/>
                 </a:solidFill>
@@ -7722,8 +7722,8 @@
         </p:nvSpPr>
         <p:spPr>
           <a:xfrm>
-            <a:off x="731520" y="1828800"/>
-            <a:ext cx="5486400" cy="4297680"/>
+            <a:off x="731520" y="1691640"/>
+            <a:ext cx="5486400" cy="4434840"/>
           </a:xfrm>
           <a:prstGeom prst="roundRect">
             <a:avLst/>
@@ -7752,14 +7752,14 @@
           </a:fontRef>
         </p:style>
         <p:txBody>
-          <a:bodyPr rtlCol="0" anchor="ctr" wrap="square" lIns="274320" rIns="274320" tIns="274320"/>
+          <a:bodyPr rtlCol="0" anchor="ctr" wrap="square" lIns="228600" rIns="228600" tIns="228600" bIns="182880"/>
           <a:lstStyle/>
           <a:p>
             <a:pPr algn="ctr">
               <a:spcBef>
                 <a:spcPts val="0"/>
               </a:spcBef>
-              <a:defRPr b="1" sz="1300">
+              <a:defRPr b="1" sz="1100">
                 <a:solidFill>
                   <a:srgbClr val="3B82F6"/>
                 </a:solidFill>
@@ -7772,9 +7772,9 @@
           <a:p>
             <a:pPr>
               <a:spcBef>
-                <a:spcPts val="200"/>
-              </a:spcBef>
-              <a:defRPr sz="1100">
+                <a:spcPts val="150"/>
+              </a:spcBef>
+              <a:defRPr sz="950">
                 <a:solidFill>
                   <a:srgbClr val="F8FAFC"/>
                 </a:solidFill>
@@ -7787,9 +7787,9 @@
           <a:p>
             <a:pPr>
               <a:spcBef>
-                <a:spcPts val="800"/>
-              </a:spcBef>
-              <a:defRPr b="1" sz="1300">
+                <a:spcPts val="500"/>
+              </a:spcBef>
+              <a:defRPr b="1" sz="1100">
                 <a:solidFill>
                   <a:srgbClr val="06B6D4"/>
                 </a:solidFill>
@@ -7802,9 +7802,9 @@
           <a:p>
             <a:pPr>
               <a:spcBef>
-                <a:spcPts val="200"/>
-              </a:spcBef>
-              <a:defRPr sz="1100">
+                <a:spcPts val="150"/>
+              </a:spcBef>
+              <a:defRPr sz="950">
                 <a:solidFill>
                   <a:srgbClr val="F8FAFC"/>
                 </a:solidFill>
@@ -7817,9 +7817,9 @@
           <a:p>
             <a:pPr>
               <a:spcBef>
-                <a:spcPts val="800"/>
-              </a:spcBef>
-              <a:defRPr b="1" sz="1300">
+                <a:spcPts val="500"/>
+              </a:spcBef>
+              <a:defRPr b="1" sz="1100">
                 <a:solidFill>
                   <a:srgbClr val="3B82F6"/>
                 </a:solidFill>
@@ -7832,9 +7832,9 @@
           <a:p>
             <a:pPr>
               <a:spcBef>
-                <a:spcPts val="200"/>
-              </a:spcBef>
-              <a:defRPr sz="1100">
+                <a:spcPts val="150"/>
+              </a:spcBef>
+              <a:defRPr sz="950">
                 <a:solidFill>
                   <a:srgbClr val="F8FAFC"/>
                 </a:solidFill>
@@ -7847,9 +7847,9 @@
           <a:p>
             <a:pPr>
               <a:spcBef>
-                <a:spcPts val="800"/>
-              </a:spcBef>
-              <a:defRPr b="1" sz="1300">
+                <a:spcPts val="500"/>
+              </a:spcBef>
+              <a:defRPr b="1" sz="1100">
                 <a:solidFill>
                   <a:srgbClr val="06B6D4"/>
                 </a:solidFill>
@@ -7862,9 +7862,9 @@
           <a:p>
             <a:pPr>
               <a:spcBef>
-                <a:spcPts val="200"/>
-              </a:spcBef>
-              <a:defRPr sz="1100">
+                <a:spcPts val="150"/>
+              </a:spcBef>
+              <a:defRPr sz="950">
                 <a:solidFill>
                   <a:srgbClr val="F8FAFC"/>
                 </a:solidFill>
@@ -7892,8 +7892,8 @@
         </p:blipFill>
         <p:spPr>
           <a:xfrm>
-            <a:off x="6492240" y="1828800"/>
-            <a:ext cx="4937760" cy="4297680"/>
+            <a:off x="6492240" y="1691640"/>
+            <a:ext cx="4937760" cy="4434840"/>
           </a:xfrm>
           <a:prstGeom prst="rect">
             <a:avLst/>
@@ -7909,7 +7909,7 @@
         <p:spPr>
           <a:xfrm>
             <a:off x="731520" y="6309360"/>
-            <a:ext cx="10728655" cy="365760"/>
+            <a:ext cx="10728655" cy="320040"/>
           </a:xfrm>
           <a:prstGeom prst="rect">
             <a:avLst/>
@@ -7923,14 +7923,14 @@
           <a:lstStyle/>
           <a:p>
             <a:pPr>
-              <a:defRPr sz="900">
+              <a:defRPr sz="850">
                 <a:solidFill>
                   <a:srgbClr val="64748B"/>
                 </a:solidFill>
               </a:defRPr>
             </a:pPr>
             <a:r>
-              <a:t>Google Cloud Hackathon 2026 | Quota Management Control Plane  •  Slide 5 of 17  •  Team: Y. Navaneeth Reddy, Shivam Kumar, Niket Kumar, Allam Sahithi</a:t>
+              <a:t>Google Cloud Hackathon 2026 | Quota Management Control Plane  •  Slide 5 of 17</a:t>
             </a:r>
           </a:p>
         </p:txBody>
@@ -8004,8 +8004,8 @@
         </p:nvSpPr>
         <p:spPr>
           <a:xfrm>
-            <a:off x="731520" y="457200"/>
-            <a:ext cx="4572000" cy="365760"/>
+            <a:off x="731520" y="411480"/>
+            <a:ext cx="5486400" cy="320040"/>
           </a:xfrm>
           <a:prstGeom prst="rect">
             <a:avLst/>
@@ -8019,7 +8019,7 @@
           <a:lstStyle/>
           <a:p>
             <a:pPr>
-              <a:defRPr sz="1000" b="1">
+              <a:defRPr sz="950" b="1">
                 <a:solidFill>
                   <a:srgbClr val="06B6D4"/>
                 </a:solidFill>
@@ -8039,8 +8039,8 @@
         </p:nvSpPr>
         <p:spPr>
           <a:xfrm>
-            <a:off x="731520" y="777240"/>
-            <a:ext cx="10515600" cy="731520"/>
+            <a:off x="731520" y="685800"/>
+            <a:ext cx="10515600" cy="594360"/>
           </a:xfrm>
           <a:prstGeom prst="rect">
             <a:avLst/>
@@ -8054,7 +8054,7 @@
           <a:lstStyle/>
           <a:p>
             <a:pPr>
-              <a:defRPr sz="2200" b="1">
+              <a:defRPr sz="2000" b="1">
                 <a:solidFill>
                   <a:srgbClr val="F8FAFC"/>
                 </a:solidFill>
@@ -8074,7 +8074,7 @@
         </p:nvSpPr>
         <p:spPr>
           <a:xfrm>
-            <a:off x="731520" y="1371600"/>
+            <a:off x="731520" y="1234440"/>
             <a:ext cx="10515600" cy="365760"/>
           </a:xfrm>
           <a:prstGeom prst="rect">
@@ -8089,7 +8089,7 @@
           <a:lstStyle/>
           <a:p>
             <a:pPr>
-              <a:defRPr sz="1200">
+              <a:defRPr sz="1100">
                 <a:solidFill>
                   <a:srgbClr val="94A3B8"/>
                 </a:solidFill>
@@ -8109,8 +8109,8 @@
         </p:nvSpPr>
         <p:spPr>
           <a:xfrm>
-            <a:off x="731520" y="1828800"/>
-            <a:ext cx="5486400" cy="4297680"/>
+            <a:off x="731520" y="1691640"/>
+            <a:ext cx="5486400" cy="4434840"/>
           </a:xfrm>
           <a:prstGeom prst="roundRect">
             <a:avLst/>
@@ -8139,14 +8139,14 @@
           </a:fontRef>
         </p:style>
         <p:txBody>
-          <a:bodyPr rtlCol="0" anchor="ctr" wrap="square" lIns="274320" rIns="274320" tIns="274320"/>
+          <a:bodyPr rtlCol="0" anchor="ctr" wrap="square" lIns="228600" rIns="228600" tIns="228600" bIns="182880"/>
           <a:lstStyle/>
           <a:p>
             <a:pPr algn="ctr">
               <a:spcBef>
                 <a:spcPts val="0"/>
               </a:spcBef>
-              <a:defRPr b="1" sz="1300">
+              <a:defRPr b="1" sz="1100">
                 <a:solidFill>
                   <a:srgbClr val="3B82F6"/>
                 </a:solidFill>
@@ -8159,9 +8159,9 @@
           <a:p>
             <a:pPr>
               <a:spcBef>
-                <a:spcPts val="200"/>
-              </a:spcBef>
-              <a:defRPr sz="1100">
+                <a:spcPts val="150"/>
+              </a:spcBef>
+              <a:defRPr sz="950">
                 <a:solidFill>
                   <a:srgbClr val="F8FAFC"/>
                 </a:solidFill>
@@ -8174,9 +8174,9 @@
           <a:p>
             <a:pPr>
               <a:spcBef>
-                <a:spcPts val="800"/>
-              </a:spcBef>
-              <a:defRPr b="1" sz="1300">
+                <a:spcPts val="500"/>
+              </a:spcBef>
+              <a:defRPr b="1" sz="1100">
                 <a:solidFill>
                   <a:srgbClr val="06B6D4"/>
                 </a:solidFill>
@@ -8189,9 +8189,9 @@
           <a:p>
             <a:pPr>
               <a:spcBef>
-                <a:spcPts val="200"/>
-              </a:spcBef>
-              <a:defRPr sz="1100">
+                <a:spcPts val="150"/>
+              </a:spcBef>
+              <a:defRPr sz="950">
                 <a:solidFill>
                   <a:srgbClr val="F8FAFC"/>
                 </a:solidFill>
@@ -8204,9 +8204,9 @@
           <a:p>
             <a:pPr>
               <a:spcBef>
-                <a:spcPts val="800"/>
-              </a:spcBef>
-              <a:defRPr b="1" sz="1300">
+                <a:spcPts val="500"/>
+              </a:spcBef>
+              <a:defRPr b="1" sz="1100">
                 <a:solidFill>
                   <a:srgbClr val="3B82F6"/>
                 </a:solidFill>
@@ -8219,9 +8219,9 @@
           <a:p>
             <a:pPr>
               <a:spcBef>
-                <a:spcPts val="200"/>
-              </a:spcBef>
-              <a:defRPr sz="1100">
+                <a:spcPts val="150"/>
+              </a:spcBef>
+              <a:defRPr sz="950">
                 <a:solidFill>
                   <a:srgbClr val="F8FAFC"/>
                 </a:solidFill>
@@ -8234,9 +8234,9 @@
           <a:p>
             <a:pPr>
               <a:spcBef>
-                <a:spcPts val="800"/>
-              </a:spcBef>
-              <a:defRPr b="1" sz="1300">
+                <a:spcPts val="500"/>
+              </a:spcBef>
+              <a:defRPr b="1" sz="1100">
                 <a:solidFill>
                   <a:srgbClr val="06B6D4"/>
                 </a:solidFill>
@@ -8249,9 +8249,9 @@
           <a:p>
             <a:pPr>
               <a:spcBef>
-                <a:spcPts val="200"/>
-              </a:spcBef>
-              <a:defRPr sz="1100">
+                <a:spcPts val="150"/>
+              </a:spcBef>
+              <a:defRPr sz="950">
                 <a:solidFill>
                   <a:srgbClr val="F8FAFC"/>
                 </a:solidFill>
@@ -8279,8 +8279,8 @@
         </p:blipFill>
         <p:spPr>
           <a:xfrm>
-            <a:off x="6492240" y="1828800"/>
-            <a:ext cx="4937760" cy="4297680"/>
+            <a:off x="6492240" y="1691640"/>
+            <a:ext cx="4937760" cy="4434840"/>
           </a:xfrm>
           <a:prstGeom prst="rect">
             <a:avLst/>
@@ -8296,7 +8296,7 @@
         <p:spPr>
           <a:xfrm>
             <a:off x="731520" y="6309360"/>
-            <a:ext cx="10728655" cy="365760"/>
+            <a:ext cx="10728655" cy="320040"/>
           </a:xfrm>
           <a:prstGeom prst="rect">
             <a:avLst/>
@@ -8310,14 +8310,14 @@
           <a:lstStyle/>
           <a:p>
             <a:pPr>
-              <a:defRPr sz="900">
+              <a:defRPr sz="850">
                 <a:solidFill>
                   <a:srgbClr val="64748B"/>
                 </a:solidFill>
               </a:defRPr>
             </a:pPr>
             <a:r>
-              <a:t>Google Cloud Hackathon 2026 | Quota Management Control Plane  •  Slide 6 of 17  •  Team: Y. Navaneeth Reddy, Shivam Kumar, Niket Kumar, Allam Sahithi</a:t>
+              <a:t>Google Cloud Hackathon 2026 | Quota Management Control Plane  •  Slide 6 of 17</a:t>
             </a:r>
           </a:p>
         </p:txBody>
@@ -8391,8 +8391,8 @@
         </p:nvSpPr>
         <p:spPr>
           <a:xfrm>
-            <a:off x="731520" y="457200"/>
-            <a:ext cx="4572000" cy="365760"/>
+            <a:off x="731520" y="411480"/>
+            <a:ext cx="5486400" cy="320040"/>
           </a:xfrm>
           <a:prstGeom prst="rect">
             <a:avLst/>
@@ -8406,7 +8406,7 @@
           <a:lstStyle/>
           <a:p>
             <a:pPr>
-              <a:defRPr sz="1000" b="1">
+              <a:defRPr sz="950" b="1">
                 <a:solidFill>
                   <a:srgbClr val="06B6D4"/>
                 </a:solidFill>
@@ -8426,8 +8426,8 @@
         </p:nvSpPr>
         <p:spPr>
           <a:xfrm>
-            <a:off x="731520" y="777240"/>
-            <a:ext cx="10515600" cy="731520"/>
+            <a:off x="731520" y="685800"/>
+            <a:ext cx="10515600" cy="594360"/>
           </a:xfrm>
           <a:prstGeom prst="rect">
             <a:avLst/>
@@ -8441,7 +8441,7 @@
           <a:lstStyle/>
           <a:p>
             <a:pPr>
-              <a:defRPr sz="2200" b="1">
+              <a:defRPr sz="2000" b="1">
                 <a:solidFill>
                   <a:srgbClr val="F8FAFC"/>
                 </a:solidFill>
@@ -8461,7 +8461,7 @@
         </p:nvSpPr>
         <p:spPr>
           <a:xfrm>
-            <a:off x="731520" y="1371600"/>
+            <a:off x="731520" y="1234440"/>
             <a:ext cx="10515600" cy="365760"/>
           </a:xfrm>
           <a:prstGeom prst="rect">
@@ -8476,7 +8476,7 @@
           <a:lstStyle/>
           <a:p>
             <a:pPr>
-              <a:defRPr sz="1200">
+              <a:defRPr sz="1100">
                 <a:solidFill>
                   <a:srgbClr val="94A3B8"/>
                 </a:solidFill>
@@ -8496,8 +8496,8 @@
         </p:nvSpPr>
         <p:spPr>
           <a:xfrm>
-            <a:off x="731520" y="1828800"/>
-            <a:ext cx="5486400" cy="4297680"/>
+            <a:off x="731520" y="1691640"/>
+            <a:ext cx="5486400" cy="4434840"/>
           </a:xfrm>
           <a:prstGeom prst="roundRect">
             <a:avLst/>
@@ -8526,14 +8526,14 @@
           </a:fontRef>
         </p:style>
         <p:txBody>
-          <a:bodyPr rtlCol="0" anchor="ctr" wrap="square" lIns="274320" rIns="274320" tIns="274320"/>
+          <a:bodyPr rtlCol="0" anchor="ctr" wrap="square" lIns="228600" rIns="228600" tIns="228600" bIns="182880"/>
           <a:lstStyle/>
           <a:p>
             <a:pPr algn="ctr">
               <a:spcBef>
                 <a:spcPts val="0"/>
               </a:spcBef>
-              <a:defRPr b="1" sz="1300">
+              <a:defRPr b="1" sz="1100">
                 <a:solidFill>
                   <a:srgbClr val="3B82F6"/>
                 </a:solidFill>
@@ -8546,9 +8546,9 @@
           <a:p>
             <a:pPr>
               <a:spcBef>
-                <a:spcPts val="200"/>
-              </a:spcBef>
-              <a:defRPr sz="1100">
+                <a:spcPts val="150"/>
+              </a:spcBef>
+              <a:defRPr sz="950">
                 <a:solidFill>
                   <a:srgbClr val="F8FAFC"/>
                 </a:solidFill>
@@ -8561,9 +8561,9 @@
           <a:p>
             <a:pPr>
               <a:spcBef>
-                <a:spcPts val="800"/>
-              </a:spcBef>
-              <a:defRPr b="1" sz="1300">
+                <a:spcPts val="500"/>
+              </a:spcBef>
+              <a:defRPr b="1" sz="1100">
                 <a:solidFill>
                   <a:srgbClr val="06B6D4"/>
                 </a:solidFill>
@@ -8576,9 +8576,9 @@
           <a:p>
             <a:pPr>
               <a:spcBef>
-                <a:spcPts val="200"/>
-              </a:spcBef>
-              <a:defRPr sz="1100">
+                <a:spcPts val="150"/>
+              </a:spcBef>
+              <a:defRPr sz="950">
                 <a:solidFill>
                   <a:srgbClr val="F8FAFC"/>
                 </a:solidFill>
@@ -8591,9 +8591,9 @@
           <a:p>
             <a:pPr>
               <a:spcBef>
-                <a:spcPts val="800"/>
-              </a:spcBef>
-              <a:defRPr b="1" sz="1300">
+                <a:spcPts val="500"/>
+              </a:spcBef>
+              <a:defRPr b="1" sz="1100">
                 <a:solidFill>
                   <a:srgbClr val="3B82F6"/>
                 </a:solidFill>
@@ -8606,9 +8606,9 @@
           <a:p>
             <a:pPr>
               <a:spcBef>
-                <a:spcPts val="200"/>
-              </a:spcBef>
-              <a:defRPr sz="1100">
+                <a:spcPts val="150"/>
+              </a:spcBef>
+              <a:defRPr sz="950">
                 <a:solidFill>
                   <a:srgbClr val="F8FAFC"/>
                 </a:solidFill>
@@ -8621,9 +8621,9 @@
           <a:p>
             <a:pPr>
               <a:spcBef>
-                <a:spcPts val="800"/>
-              </a:spcBef>
-              <a:defRPr b="1" sz="1300">
+                <a:spcPts val="500"/>
+              </a:spcBef>
+              <a:defRPr b="1" sz="1100">
                 <a:solidFill>
                   <a:srgbClr val="06B6D4"/>
                 </a:solidFill>
@@ -8636,9 +8636,9 @@
           <a:p>
             <a:pPr>
               <a:spcBef>
-                <a:spcPts val="200"/>
-              </a:spcBef>
-              <a:defRPr sz="1100">
+                <a:spcPts val="150"/>
+              </a:spcBef>
+              <a:defRPr sz="950">
                 <a:solidFill>
                   <a:srgbClr val="F8FAFC"/>
                 </a:solidFill>
@@ -8666,8 +8666,8 @@
         </p:blipFill>
         <p:spPr>
           <a:xfrm>
-            <a:off x="6492240" y="1828800"/>
-            <a:ext cx="4937760" cy="4297680"/>
+            <a:off x="6492240" y="1691640"/>
+            <a:ext cx="4937760" cy="4434840"/>
           </a:xfrm>
           <a:prstGeom prst="rect">
             <a:avLst/>
@@ -8683,7 +8683,7 @@
         <p:spPr>
           <a:xfrm>
             <a:off x="731520" y="6309360"/>
-            <a:ext cx="10728655" cy="365760"/>
+            <a:ext cx="10728655" cy="320040"/>
           </a:xfrm>
           <a:prstGeom prst="rect">
             <a:avLst/>
@@ -8697,14 +8697,14 @@
           <a:lstStyle/>
           <a:p>
             <a:pPr>
-              <a:defRPr sz="900">
+              <a:defRPr sz="850">
                 <a:solidFill>
                   <a:srgbClr val="64748B"/>
                 </a:solidFill>
               </a:defRPr>
             </a:pPr>
             <a:r>
-              <a:t>Google Cloud Hackathon 2026 | Quota Management Control Plane  •  Slide 7 of 17  •  Team: Y. Navaneeth Reddy, Shivam Kumar, Niket Kumar, Allam Sahithi</a:t>
+              <a:t>Google Cloud Hackathon 2026 | Quota Management Control Plane  •  Slide 7 of 17</a:t>
             </a:r>
           </a:p>
         </p:txBody>
@@ -8778,8 +8778,8 @@
         </p:nvSpPr>
         <p:spPr>
           <a:xfrm>
-            <a:off x="731520" y="457200"/>
-            <a:ext cx="4572000" cy="365760"/>
+            <a:off x="731520" y="411480"/>
+            <a:ext cx="5486400" cy="320040"/>
           </a:xfrm>
           <a:prstGeom prst="rect">
             <a:avLst/>
@@ -8793,7 +8793,7 @@
           <a:lstStyle/>
           <a:p>
             <a:pPr>
-              <a:defRPr sz="1000" b="1">
+              <a:defRPr sz="950" b="1">
                 <a:solidFill>
                   <a:srgbClr val="06B6D4"/>
                 </a:solidFill>
@@ -8813,8 +8813,8 @@
         </p:nvSpPr>
         <p:spPr>
           <a:xfrm>
-            <a:off x="731520" y="777240"/>
-            <a:ext cx="10515600" cy="731520"/>
+            <a:off x="731520" y="685800"/>
+            <a:ext cx="10515600" cy="594360"/>
           </a:xfrm>
           <a:prstGeom prst="rect">
             <a:avLst/>
@@ -8828,7 +8828,7 @@
           <a:lstStyle/>
           <a:p>
             <a:pPr>
-              <a:defRPr sz="2200" b="1">
+              <a:defRPr sz="2000" b="1">
                 <a:solidFill>
                   <a:srgbClr val="F8FAFC"/>
                 </a:solidFill>
@@ -8848,7 +8848,7 @@
         </p:nvSpPr>
         <p:spPr>
           <a:xfrm>
-            <a:off x="731520" y="1371600"/>
+            <a:off x="731520" y="1234440"/>
             <a:ext cx="10515600" cy="365760"/>
           </a:xfrm>
           <a:prstGeom prst="rect">
@@ -8863,7 +8863,7 @@
           <a:lstStyle/>
           <a:p>
             <a:pPr>
-              <a:defRPr sz="1200">
+              <a:defRPr sz="1100">
                 <a:solidFill>
                   <a:srgbClr val="94A3B8"/>
                 </a:solidFill>
@@ -8883,8 +8883,8 @@
         </p:nvSpPr>
         <p:spPr>
           <a:xfrm>
-            <a:off x="731520" y="1828800"/>
-            <a:ext cx="5486400" cy="4297680"/>
+            <a:off x="731520" y="1691640"/>
+            <a:ext cx="5486400" cy="4434840"/>
           </a:xfrm>
           <a:prstGeom prst="roundRect">
             <a:avLst/>
@@ -8913,14 +8913,14 @@
           </a:fontRef>
         </p:style>
         <p:txBody>
-          <a:bodyPr rtlCol="0" anchor="ctr" wrap="square" lIns="274320" rIns="274320" tIns="274320"/>
+          <a:bodyPr rtlCol="0" anchor="ctr" wrap="square" lIns="228600" rIns="228600" tIns="228600" bIns="182880"/>
           <a:lstStyle/>
           <a:p>
             <a:pPr algn="ctr">
               <a:spcBef>
                 <a:spcPts val="0"/>
               </a:spcBef>
-              <a:defRPr b="1" sz="1300">
+              <a:defRPr b="1" sz="1100">
                 <a:solidFill>
                   <a:srgbClr val="3B82F6"/>
                 </a:solidFill>
@@ -8933,9 +8933,9 @@
           <a:p>
             <a:pPr>
               <a:spcBef>
-                <a:spcPts val="200"/>
-              </a:spcBef>
-              <a:defRPr sz="1100">
+                <a:spcPts val="150"/>
+              </a:spcBef>
+              <a:defRPr sz="950">
                 <a:solidFill>
                   <a:srgbClr val="F8FAFC"/>
                 </a:solidFill>
@@ -8948,9 +8948,9 @@
           <a:p>
             <a:pPr>
               <a:spcBef>
-                <a:spcPts val="800"/>
-              </a:spcBef>
-              <a:defRPr b="1" sz="1300">
+                <a:spcPts val="500"/>
+              </a:spcBef>
+              <a:defRPr b="1" sz="1100">
                 <a:solidFill>
                   <a:srgbClr val="06B6D4"/>
                 </a:solidFill>
@@ -8963,9 +8963,9 @@
           <a:p>
             <a:pPr>
               <a:spcBef>
-                <a:spcPts val="200"/>
-              </a:spcBef>
-              <a:defRPr sz="1100">
+                <a:spcPts val="150"/>
+              </a:spcBef>
+              <a:defRPr sz="950">
                 <a:solidFill>
                   <a:srgbClr val="F8FAFC"/>
                 </a:solidFill>
@@ -8978,9 +8978,9 @@
           <a:p>
             <a:pPr>
               <a:spcBef>
-                <a:spcPts val="800"/>
-              </a:spcBef>
-              <a:defRPr b="1" sz="1300">
+                <a:spcPts val="500"/>
+              </a:spcBef>
+              <a:defRPr b="1" sz="1100">
                 <a:solidFill>
                   <a:srgbClr val="3B82F6"/>
                 </a:solidFill>
@@ -8993,9 +8993,9 @@
           <a:p>
             <a:pPr>
               <a:spcBef>
-                <a:spcPts val="200"/>
-              </a:spcBef>
-              <a:defRPr sz="1100">
+                <a:spcPts val="150"/>
+              </a:spcBef>
+              <a:defRPr sz="950">
                 <a:solidFill>
                   <a:srgbClr val="F8FAFC"/>
                 </a:solidFill>
@@ -9008,9 +9008,9 @@
           <a:p>
             <a:pPr>
               <a:spcBef>
-                <a:spcPts val="800"/>
-              </a:spcBef>
-              <a:defRPr b="1" sz="1300">
+                <a:spcPts val="500"/>
+              </a:spcBef>
+              <a:defRPr b="1" sz="1100">
                 <a:solidFill>
                   <a:srgbClr val="06B6D4"/>
                 </a:solidFill>
@@ -9023,9 +9023,9 @@
           <a:p>
             <a:pPr>
               <a:spcBef>
-                <a:spcPts val="200"/>
-              </a:spcBef>
-              <a:defRPr sz="1100">
+                <a:spcPts val="150"/>
+              </a:spcBef>
+              <a:defRPr sz="950">
                 <a:solidFill>
                   <a:srgbClr val="F8FAFC"/>
                 </a:solidFill>
@@ -9053,8 +9053,8 @@
         </p:blipFill>
         <p:spPr>
           <a:xfrm>
-            <a:off x="6492240" y="1828800"/>
-            <a:ext cx="4937760" cy="4297680"/>
+            <a:off x="6492240" y="1691640"/>
+            <a:ext cx="4937760" cy="4434840"/>
           </a:xfrm>
           <a:prstGeom prst="rect">
             <a:avLst/>
@@ -9070,7 +9070,7 @@
         <p:spPr>
           <a:xfrm>
             <a:off x="731520" y="6309360"/>
-            <a:ext cx="10728655" cy="365760"/>
+            <a:ext cx="10728655" cy="320040"/>
           </a:xfrm>
           <a:prstGeom prst="rect">
             <a:avLst/>
@@ -9084,14 +9084,14 @@
           <a:lstStyle/>
           <a:p>
             <a:pPr>
-              <a:defRPr sz="900">
+              <a:defRPr sz="850">
                 <a:solidFill>
                   <a:srgbClr val="64748B"/>
                 </a:solidFill>
               </a:defRPr>
             </a:pPr>
             <a:r>
-              <a:t>Google Cloud Hackathon 2026 | Quota Management Control Plane  •  Slide 8 of 17  •  Team: Y. Navaneeth Reddy, Shivam Kumar, Niket Kumar, Allam Sahithi</a:t>
+              <a:t>Google Cloud Hackathon 2026 | Quota Management Control Plane  •  Slide 8 of 17</a:t>
             </a:r>
           </a:p>
         </p:txBody>
@@ -9165,8 +9165,8 @@
         </p:nvSpPr>
         <p:spPr>
           <a:xfrm>
-            <a:off x="731520" y="457200"/>
-            <a:ext cx="4572000" cy="365760"/>
+            <a:off x="731520" y="411480"/>
+            <a:ext cx="5486400" cy="320040"/>
           </a:xfrm>
           <a:prstGeom prst="rect">
             <a:avLst/>
@@ -9180,7 +9180,7 @@
           <a:lstStyle/>
           <a:p>
             <a:pPr>
-              <a:defRPr sz="1000" b="1">
+              <a:defRPr sz="950" b="1">
                 <a:solidFill>
                   <a:srgbClr val="06B6D4"/>
                 </a:solidFill>
@@ -9200,8 +9200,8 @@
         </p:nvSpPr>
         <p:spPr>
           <a:xfrm>
-            <a:off x="731520" y="777240"/>
-            <a:ext cx="10515600" cy="731520"/>
+            <a:off x="731520" y="685800"/>
+            <a:ext cx="10515600" cy="594360"/>
           </a:xfrm>
           <a:prstGeom prst="rect">
             <a:avLst/>
@@ -9215,7 +9215,7 @@
           <a:lstStyle/>
           <a:p>
             <a:pPr>
-              <a:defRPr sz="2200" b="1">
+              <a:defRPr sz="2000" b="1">
                 <a:solidFill>
                   <a:srgbClr val="F8FAFC"/>
                 </a:solidFill>
@@ -9235,7 +9235,7 @@
         </p:nvSpPr>
         <p:spPr>
           <a:xfrm>
-            <a:off x="731520" y="1371600"/>
+            <a:off x="731520" y="1234440"/>
             <a:ext cx="10515600" cy="365760"/>
           </a:xfrm>
           <a:prstGeom prst="rect">
@@ -9250,7 +9250,7 @@
           <a:lstStyle/>
           <a:p>
             <a:pPr>
-              <a:defRPr sz="1200">
+              <a:defRPr sz="1100">
                 <a:solidFill>
                   <a:srgbClr val="94A3B8"/>
                 </a:solidFill>
@@ -9270,8 +9270,8 @@
         </p:nvSpPr>
         <p:spPr>
           <a:xfrm>
-            <a:off x="731520" y="1828800"/>
-            <a:ext cx="5486400" cy="4297680"/>
+            <a:off x="731520" y="1691640"/>
+            <a:ext cx="5486400" cy="4434840"/>
           </a:xfrm>
           <a:prstGeom prst="roundRect">
             <a:avLst/>
@@ -9300,14 +9300,14 @@
           </a:fontRef>
         </p:style>
         <p:txBody>
-          <a:bodyPr rtlCol="0" anchor="ctr" wrap="square" lIns="274320" rIns="274320" tIns="274320"/>
+          <a:bodyPr rtlCol="0" anchor="ctr" wrap="square" lIns="228600" rIns="228600" tIns="228600" bIns="182880"/>
           <a:lstStyle/>
           <a:p>
             <a:pPr algn="ctr">
               <a:spcBef>
                 <a:spcPts val="0"/>
               </a:spcBef>
-              <a:defRPr b="1" sz="1300">
+              <a:defRPr b="1" sz="1100">
                 <a:solidFill>
                   <a:srgbClr val="3B82F6"/>
                 </a:solidFill>
@@ -9320,9 +9320,9 @@
           <a:p>
             <a:pPr>
               <a:spcBef>
-                <a:spcPts val="200"/>
-              </a:spcBef>
-              <a:defRPr sz="1100">
+                <a:spcPts val="150"/>
+              </a:spcBef>
+              <a:defRPr sz="950">
                 <a:solidFill>
                   <a:srgbClr val="F8FAFC"/>
                 </a:solidFill>
@@ -9335,9 +9335,9 @@
           <a:p>
             <a:pPr>
               <a:spcBef>
-                <a:spcPts val="800"/>
-              </a:spcBef>
-              <a:defRPr b="1" sz="1300">
+                <a:spcPts val="500"/>
+              </a:spcBef>
+              <a:defRPr b="1" sz="1100">
                 <a:solidFill>
                   <a:srgbClr val="06B6D4"/>
                 </a:solidFill>
@@ -9350,9 +9350,9 @@
           <a:p>
             <a:pPr>
               <a:spcBef>
-                <a:spcPts val="200"/>
-              </a:spcBef>
-              <a:defRPr sz="1100">
+                <a:spcPts val="150"/>
+              </a:spcBef>
+              <a:defRPr sz="950">
                 <a:solidFill>
                   <a:srgbClr val="F8FAFC"/>
                 </a:solidFill>
@@ -9365,9 +9365,9 @@
           <a:p>
             <a:pPr>
               <a:spcBef>
-                <a:spcPts val="800"/>
-              </a:spcBef>
-              <a:defRPr b="1" sz="1300">
+                <a:spcPts val="500"/>
+              </a:spcBef>
+              <a:defRPr b="1" sz="1100">
                 <a:solidFill>
                   <a:srgbClr val="3B82F6"/>
                 </a:solidFill>
@@ -9380,9 +9380,9 @@
           <a:p>
             <a:pPr>
               <a:spcBef>
-                <a:spcPts val="200"/>
-              </a:spcBef>
-              <a:defRPr sz="1100">
+                <a:spcPts val="150"/>
+              </a:spcBef>
+              <a:defRPr sz="950">
                 <a:solidFill>
                   <a:srgbClr val="F8FAFC"/>
                 </a:solidFill>
@@ -9395,9 +9395,9 @@
           <a:p>
             <a:pPr>
               <a:spcBef>
-                <a:spcPts val="800"/>
-              </a:spcBef>
-              <a:defRPr b="1" sz="1300">
+                <a:spcPts val="500"/>
+              </a:spcBef>
+              <a:defRPr b="1" sz="1100">
                 <a:solidFill>
                   <a:srgbClr val="06B6D4"/>
                 </a:solidFill>
@@ -9410,9 +9410,9 @@
           <a:p>
             <a:pPr>
               <a:spcBef>
-                <a:spcPts val="200"/>
-              </a:spcBef>
-              <a:defRPr sz="1100">
+                <a:spcPts val="150"/>
+              </a:spcBef>
+              <a:defRPr sz="950">
                 <a:solidFill>
                   <a:srgbClr val="F8FAFC"/>
                 </a:solidFill>
@@ -9440,8 +9440,8 @@
         </p:blipFill>
         <p:spPr>
           <a:xfrm>
-            <a:off x="6492240" y="1828800"/>
-            <a:ext cx="4937760" cy="4297680"/>
+            <a:off x="6492240" y="1691640"/>
+            <a:ext cx="4937760" cy="4434840"/>
           </a:xfrm>
           <a:prstGeom prst="rect">
             <a:avLst/>
@@ -9457,7 +9457,7 @@
         <p:spPr>
           <a:xfrm>
             <a:off x="731520" y="6309360"/>
-            <a:ext cx="10728655" cy="365760"/>
+            <a:ext cx="10728655" cy="320040"/>
           </a:xfrm>
           <a:prstGeom prst="rect">
             <a:avLst/>
@@ -9471,14 +9471,14 @@
           <a:lstStyle/>
           <a:p>
             <a:pPr>
-              <a:defRPr sz="900">
+              <a:defRPr sz="850">
                 <a:solidFill>
                   <a:srgbClr val="64748B"/>
                 </a:solidFill>
               </a:defRPr>
             </a:pPr>
             <a:r>
-              <a:t>Google Cloud Hackathon 2026 | Quota Management Control Plane  •  Slide 9 of 17  •  Team: Y. Navaneeth Reddy, Shivam Kumar, Niket Kumar, Allam Sahithi</a:t>
+              <a:t>Google Cloud Hackathon 2026 | Quota Management Control Plane  •  Slide 9 of 17</a:t>
             </a:r>
           </a:p>
         </p:txBody>

</xml_diff>